<commit_message>
Update: 카메라 enable momentum false 처리
</commit_message>
<xml_diff>
--- a/PPT/week1.pptx
+++ b/PPT/week1.pptx
@@ -265,38 +265,37 @@
           <a:p>
             <a:pPr lvl="0"/>
             <a:r>
-              <a:rPr lang="ko-KR" altLang="en-US" smtClean="0"/>
+              <a:rPr lang="ko-KR" altLang="en-US"/>
               <a:t>마스터 텍스트 스타일을 편집합니다</a:t>
             </a:r>
           </a:p>
           <a:p>
             <a:pPr lvl="1"/>
             <a:r>
-              <a:rPr lang="ko-KR" altLang="en-US" smtClean="0"/>
+              <a:rPr lang="ko-KR" altLang="en-US"/>
               <a:t>둘째 수준</a:t>
             </a:r>
           </a:p>
           <a:p>
             <a:pPr lvl="2"/>
             <a:r>
-              <a:rPr lang="ko-KR" altLang="en-US" smtClean="0"/>
+              <a:rPr lang="ko-KR" altLang="en-US"/>
               <a:t>셋째 수준</a:t>
             </a:r>
           </a:p>
           <a:p>
             <a:pPr lvl="3"/>
             <a:r>
-              <a:rPr lang="ko-KR" altLang="en-US" smtClean="0"/>
+              <a:rPr lang="ko-KR" altLang="en-US"/>
               <a:t>넷째 수준</a:t>
             </a:r>
           </a:p>
           <a:p>
             <a:pPr lvl="4"/>
             <a:r>
-              <a:rPr lang="ko-KR" altLang="en-US" smtClean="0"/>
+              <a:rPr lang="ko-KR" altLang="en-US"/>
               <a:t>다섯째 수준</a:t>
             </a:r>
-            <a:endParaRPr lang="ko-KR" altLang="en-US"/>
           </a:p>
         </p:txBody>
       </p:sp>
@@ -682,11 +681,11 @@
           <a:lstStyle/>
           <a:p>
             <a:r>
-              <a:rPr lang="ko-KR" altLang="en-US" dirty="0" smtClean="0"/>
+              <a:rPr lang="ko-KR" altLang="en-US" dirty="0"/>
               <a:t>목표 영상 </a:t>
             </a:r>
             <a:r>
-              <a:rPr lang="en-US" altLang="ko-KR" dirty="0" smtClean="0"/>
+              <a:rPr lang="en-US" altLang="ko-KR" dirty="0"/>
               <a:t>: </a:t>
             </a:r>
           </a:p>
@@ -695,29 +694,29 @@
               <a:buAutoNum type="arabicPeriod"/>
             </a:pPr>
             <a:r>
-              <a:rPr lang="ko-KR" altLang="en-US" dirty="0" err="1" smtClean="0"/>
+              <a:rPr lang="ko-KR" altLang="en-US" dirty="0" err="1"/>
               <a:t>어쌔신크리드</a:t>
             </a:r>
             <a:r>
-              <a:rPr lang="ko-KR" altLang="en-US" dirty="0" smtClean="0"/>
+              <a:rPr lang="ko-KR" altLang="en-US" dirty="0"/>
               <a:t> </a:t>
             </a:r>
             <a:r>
-              <a:rPr lang="ko-KR" altLang="en-US" dirty="0" err="1" smtClean="0"/>
+              <a:rPr lang="ko-KR" altLang="en-US" dirty="0" err="1"/>
               <a:t>파쿠르</a:t>
             </a:r>
             <a:r>
-              <a:rPr lang="ko-KR" altLang="en-US" dirty="0" smtClean="0"/>
+              <a:rPr lang="ko-KR" altLang="en-US" dirty="0"/>
               <a:t> 액션 </a:t>
             </a:r>
-            <a:endParaRPr lang="en-US" altLang="ko-KR" dirty="0" smtClean="0"/>
+            <a:endParaRPr lang="en-US" altLang="ko-KR" dirty="0"/>
           </a:p>
           <a:p>
             <a:pPr marL="685800" lvl="1" indent="-228600">
               <a:buAutoNum type="arabicPeriod"/>
             </a:pPr>
             <a:r>
-              <a:rPr lang="en-US" altLang="ko-KR" dirty="0" smtClean="0"/>
+              <a:rPr lang="en-US" altLang="ko-KR" dirty="0"/>
               <a:t>https://www.youtube.com/shorts/DgF8jxONRSM</a:t>
             </a:r>
           </a:p>
@@ -726,7 +725,7 @@
               <a:buAutoNum type="arabicPeriod"/>
             </a:pPr>
             <a:r>
-              <a:rPr lang="en-US" altLang="ko-KR" dirty="0" smtClean="0"/>
+              <a:rPr lang="en-US" altLang="ko-KR" dirty="0"/>
               <a:t>https://www.youtube.com/shorts/bMgaW5dvLzk</a:t>
             </a:r>
           </a:p>
@@ -735,7 +734,7 @@
               <a:buAutoNum type="arabicPeriod"/>
             </a:pPr>
             <a:r>
-              <a:rPr lang="en-US" altLang="ko-KR" dirty="0" smtClean="0"/>
+              <a:rPr lang="en-US" altLang="ko-KR" dirty="0"/>
               <a:t>https://www.youtube.com/watch?v=1vhC870Phb0</a:t>
             </a:r>
           </a:p>
@@ -744,7 +743,7 @@
               <a:buAutoNum type="arabicPeriod"/>
             </a:pPr>
             <a:r>
-              <a:rPr lang="en-US" altLang="ko-KR" dirty="0" smtClean="0"/>
+              <a:rPr lang="en-US" altLang="ko-KR" dirty="0"/>
               <a:t>https://www.youtube.com/shorts/AZEMIHgBK1E</a:t>
             </a:r>
           </a:p>
@@ -753,17 +752,17 @@
               <a:buAutoNum type="arabicPeriod"/>
             </a:pPr>
             <a:r>
-              <a:rPr lang="ko-KR" altLang="en-US" dirty="0" err="1" smtClean="0"/>
+              <a:rPr lang="ko-KR" altLang="en-US" dirty="0" err="1"/>
               <a:t>툼레이더</a:t>
             </a:r>
-            <a:endParaRPr lang="en-US" altLang="ko-KR" dirty="0" smtClean="0"/>
+            <a:endParaRPr lang="en-US" altLang="ko-KR" dirty="0"/>
           </a:p>
           <a:p>
             <a:pPr marL="685800" lvl="1" indent="-228600">
               <a:buAutoNum type="arabicPeriod"/>
             </a:pPr>
             <a:r>
-              <a:rPr lang="en-US" altLang="ko-KR" dirty="0" smtClean="0"/>
+              <a:rPr lang="en-US" altLang="ko-KR" dirty="0"/>
               <a:t>https://www.youtube.com/watch?v=reqY7n8hdSg</a:t>
             </a:r>
           </a:p>
@@ -772,7 +771,7 @@
               <a:buAutoNum type="arabicPeriod"/>
             </a:pPr>
             <a:r>
-              <a:rPr lang="en-US" altLang="ko-KR" dirty="0" smtClean="0"/>
+              <a:rPr lang="en-US" altLang="ko-KR" dirty="0"/>
               <a:t>https://www.youtube.com/shorts/PLTIvSb6AxM</a:t>
             </a:r>
           </a:p>
@@ -836,7 +835,7 @@
           <p:cNvPr id="2" name="제목 1">
             <a:extLst>
               <a:ext uri="{FF2B5EF4-FFF2-40B4-BE49-F238E27FC236}">
-                <a16:creationId xmlns="" xmlns:a16="http://schemas.microsoft.com/office/drawing/2014/main" id="{47C6A88D-EDAF-CEC2-712F-FA6A7E4FF53C}"/>
+                <a16:creationId xmlns:a16="http://schemas.microsoft.com/office/drawing/2014/main" id="{47C6A88D-EDAF-CEC2-712F-FA6A7E4FF53C}"/>
               </a:ext>
             </a:extLst>
           </p:cNvPr>
@@ -873,7 +872,7 @@
           <p:cNvPr id="3" name="부제목 2">
             <a:extLst>
               <a:ext uri="{FF2B5EF4-FFF2-40B4-BE49-F238E27FC236}">
-                <a16:creationId xmlns="" xmlns:a16="http://schemas.microsoft.com/office/drawing/2014/main" id="{1F7A10E8-4E5D-A611-E577-EBA5676A507E}"/>
+                <a16:creationId xmlns:a16="http://schemas.microsoft.com/office/drawing/2014/main" id="{1F7A10E8-4E5D-A611-E577-EBA5676A507E}"/>
               </a:ext>
             </a:extLst>
           </p:cNvPr>
@@ -943,7 +942,7 @@
           <p:cNvPr id="4" name="날짜 개체 틀 3">
             <a:extLst>
               <a:ext uri="{FF2B5EF4-FFF2-40B4-BE49-F238E27FC236}">
-                <a16:creationId xmlns="" xmlns:a16="http://schemas.microsoft.com/office/drawing/2014/main" id="{FA4EF1CD-FA03-944B-0EC0-2AABE3B0C471}"/>
+                <a16:creationId xmlns:a16="http://schemas.microsoft.com/office/drawing/2014/main" id="{FA4EF1CD-FA03-944B-0EC0-2AABE3B0C471}"/>
               </a:ext>
             </a:extLst>
           </p:cNvPr>
@@ -972,7 +971,7 @@
           <p:cNvPr id="5" name="바닥글 개체 틀 4">
             <a:extLst>
               <a:ext uri="{FF2B5EF4-FFF2-40B4-BE49-F238E27FC236}">
-                <a16:creationId xmlns="" xmlns:a16="http://schemas.microsoft.com/office/drawing/2014/main" id="{D7E1904F-F41F-7809-481D-7E79FCD2132E}"/>
+                <a16:creationId xmlns:a16="http://schemas.microsoft.com/office/drawing/2014/main" id="{D7E1904F-F41F-7809-481D-7E79FCD2132E}"/>
               </a:ext>
             </a:extLst>
           </p:cNvPr>
@@ -997,7 +996,7 @@
           <p:cNvPr id="6" name="슬라이드 번호 개체 틀 5">
             <a:extLst>
               <a:ext uri="{FF2B5EF4-FFF2-40B4-BE49-F238E27FC236}">
-                <a16:creationId xmlns="" xmlns:a16="http://schemas.microsoft.com/office/drawing/2014/main" id="{46C721DE-9DEE-BACB-B354-8E260F43215D}"/>
+                <a16:creationId xmlns:a16="http://schemas.microsoft.com/office/drawing/2014/main" id="{46C721DE-9DEE-BACB-B354-8E260F43215D}"/>
               </a:ext>
             </a:extLst>
           </p:cNvPr>
@@ -1056,7 +1055,7 @@
           <p:cNvPr id="2" name="제목 1">
             <a:extLst>
               <a:ext uri="{FF2B5EF4-FFF2-40B4-BE49-F238E27FC236}">
-                <a16:creationId xmlns="" xmlns:a16="http://schemas.microsoft.com/office/drawing/2014/main" id="{8EC6E50E-2954-B290-1563-C4936B9E8431}"/>
+                <a16:creationId xmlns:a16="http://schemas.microsoft.com/office/drawing/2014/main" id="{8EC6E50E-2954-B290-1563-C4936B9E8431}"/>
               </a:ext>
             </a:extLst>
           </p:cNvPr>
@@ -1084,7 +1083,7 @@
           <p:cNvPr id="3" name="세로 텍스트 개체 틀 2">
             <a:extLst>
               <a:ext uri="{FF2B5EF4-FFF2-40B4-BE49-F238E27FC236}">
-                <a16:creationId xmlns="" xmlns:a16="http://schemas.microsoft.com/office/drawing/2014/main" id="{5B6A99E4-1414-E268-7B72-A4C896708AE3}"/>
+                <a16:creationId xmlns:a16="http://schemas.microsoft.com/office/drawing/2014/main" id="{5B6A99E4-1414-E268-7B72-A4C896708AE3}"/>
               </a:ext>
             </a:extLst>
           </p:cNvPr>
@@ -1141,7 +1140,7 @@
           <p:cNvPr id="4" name="날짜 개체 틀 3">
             <a:extLst>
               <a:ext uri="{FF2B5EF4-FFF2-40B4-BE49-F238E27FC236}">
-                <a16:creationId xmlns="" xmlns:a16="http://schemas.microsoft.com/office/drawing/2014/main" id="{3A9BB3C2-1FA4-4151-9ADB-996284F1BDE2}"/>
+                <a16:creationId xmlns:a16="http://schemas.microsoft.com/office/drawing/2014/main" id="{3A9BB3C2-1FA4-4151-9ADB-996284F1BDE2}"/>
               </a:ext>
             </a:extLst>
           </p:cNvPr>
@@ -1170,7 +1169,7 @@
           <p:cNvPr id="5" name="바닥글 개체 틀 4">
             <a:extLst>
               <a:ext uri="{FF2B5EF4-FFF2-40B4-BE49-F238E27FC236}">
-                <a16:creationId xmlns="" xmlns:a16="http://schemas.microsoft.com/office/drawing/2014/main" id="{8A27C81A-BE4E-27CE-6CE4-0AE5876D470A}"/>
+                <a16:creationId xmlns:a16="http://schemas.microsoft.com/office/drawing/2014/main" id="{8A27C81A-BE4E-27CE-6CE4-0AE5876D470A}"/>
               </a:ext>
             </a:extLst>
           </p:cNvPr>
@@ -1195,7 +1194,7 @@
           <p:cNvPr id="6" name="슬라이드 번호 개체 틀 5">
             <a:extLst>
               <a:ext uri="{FF2B5EF4-FFF2-40B4-BE49-F238E27FC236}">
-                <a16:creationId xmlns="" xmlns:a16="http://schemas.microsoft.com/office/drawing/2014/main" id="{B4E3C814-C417-2E3F-F02B-1B9ED6941FBD}"/>
+                <a16:creationId xmlns:a16="http://schemas.microsoft.com/office/drawing/2014/main" id="{B4E3C814-C417-2E3F-F02B-1B9ED6941FBD}"/>
               </a:ext>
             </a:extLst>
           </p:cNvPr>
@@ -1254,7 +1253,7 @@
           <p:cNvPr id="2" name="세로 제목 1">
             <a:extLst>
               <a:ext uri="{FF2B5EF4-FFF2-40B4-BE49-F238E27FC236}">
-                <a16:creationId xmlns="" xmlns:a16="http://schemas.microsoft.com/office/drawing/2014/main" id="{AC1D687F-54E9-57A3-FDA2-5A8060E79A80}"/>
+                <a16:creationId xmlns:a16="http://schemas.microsoft.com/office/drawing/2014/main" id="{AC1D687F-54E9-57A3-FDA2-5A8060E79A80}"/>
               </a:ext>
             </a:extLst>
           </p:cNvPr>
@@ -1287,7 +1286,7 @@
           <p:cNvPr id="3" name="세로 텍스트 개체 틀 2">
             <a:extLst>
               <a:ext uri="{FF2B5EF4-FFF2-40B4-BE49-F238E27FC236}">
-                <a16:creationId xmlns="" xmlns:a16="http://schemas.microsoft.com/office/drawing/2014/main" id="{BC846A14-940B-8FE8-A769-3DABAE11AD25}"/>
+                <a16:creationId xmlns:a16="http://schemas.microsoft.com/office/drawing/2014/main" id="{BC846A14-940B-8FE8-A769-3DABAE11AD25}"/>
               </a:ext>
             </a:extLst>
           </p:cNvPr>
@@ -1349,7 +1348,7 @@
           <p:cNvPr id="4" name="날짜 개체 틀 3">
             <a:extLst>
               <a:ext uri="{FF2B5EF4-FFF2-40B4-BE49-F238E27FC236}">
-                <a16:creationId xmlns="" xmlns:a16="http://schemas.microsoft.com/office/drawing/2014/main" id="{393732A3-4427-5A76-3A9C-DBE87A4364DD}"/>
+                <a16:creationId xmlns:a16="http://schemas.microsoft.com/office/drawing/2014/main" id="{393732A3-4427-5A76-3A9C-DBE87A4364DD}"/>
               </a:ext>
             </a:extLst>
           </p:cNvPr>
@@ -1378,7 +1377,7 @@
           <p:cNvPr id="5" name="바닥글 개체 틀 4">
             <a:extLst>
               <a:ext uri="{FF2B5EF4-FFF2-40B4-BE49-F238E27FC236}">
-                <a16:creationId xmlns="" xmlns:a16="http://schemas.microsoft.com/office/drawing/2014/main" id="{16A5B672-F383-0FF5-2D72-72E1E7F0F0D3}"/>
+                <a16:creationId xmlns:a16="http://schemas.microsoft.com/office/drawing/2014/main" id="{16A5B672-F383-0FF5-2D72-72E1E7F0F0D3}"/>
               </a:ext>
             </a:extLst>
           </p:cNvPr>
@@ -1403,7 +1402,7 @@
           <p:cNvPr id="6" name="슬라이드 번호 개체 틀 5">
             <a:extLst>
               <a:ext uri="{FF2B5EF4-FFF2-40B4-BE49-F238E27FC236}">
-                <a16:creationId xmlns="" xmlns:a16="http://schemas.microsoft.com/office/drawing/2014/main" id="{DE28928A-9906-D889-A8B7-B97D729CDB76}"/>
+                <a16:creationId xmlns:a16="http://schemas.microsoft.com/office/drawing/2014/main" id="{DE28928A-9906-D889-A8B7-B97D729CDB76}"/>
               </a:ext>
             </a:extLst>
           </p:cNvPr>
@@ -1462,7 +1461,7 @@
           <p:cNvPr id="2" name="제목 1">
             <a:extLst>
               <a:ext uri="{FF2B5EF4-FFF2-40B4-BE49-F238E27FC236}">
-                <a16:creationId xmlns="" xmlns:a16="http://schemas.microsoft.com/office/drawing/2014/main" id="{54F5793F-94FE-56B0-E0CB-A317DA7FB4BC}"/>
+                <a16:creationId xmlns:a16="http://schemas.microsoft.com/office/drawing/2014/main" id="{54F5793F-94FE-56B0-E0CB-A317DA7FB4BC}"/>
               </a:ext>
             </a:extLst>
           </p:cNvPr>
@@ -1490,7 +1489,7 @@
           <p:cNvPr id="3" name="내용 개체 틀 2">
             <a:extLst>
               <a:ext uri="{FF2B5EF4-FFF2-40B4-BE49-F238E27FC236}">
-                <a16:creationId xmlns="" xmlns:a16="http://schemas.microsoft.com/office/drawing/2014/main" id="{BFAF79B8-2AD1-69C6-D4D5-21827C6802F8}"/>
+                <a16:creationId xmlns:a16="http://schemas.microsoft.com/office/drawing/2014/main" id="{BFAF79B8-2AD1-69C6-D4D5-21827C6802F8}"/>
               </a:ext>
             </a:extLst>
           </p:cNvPr>
@@ -1547,7 +1546,7 @@
           <p:cNvPr id="4" name="날짜 개체 틀 3">
             <a:extLst>
               <a:ext uri="{FF2B5EF4-FFF2-40B4-BE49-F238E27FC236}">
-                <a16:creationId xmlns="" xmlns:a16="http://schemas.microsoft.com/office/drawing/2014/main" id="{6718AF63-4F49-82B6-24FC-BB457FC964FC}"/>
+                <a16:creationId xmlns:a16="http://schemas.microsoft.com/office/drawing/2014/main" id="{6718AF63-4F49-82B6-24FC-BB457FC964FC}"/>
               </a:ext>
             </a:extLst>
           </p:cNvPr>
@@ -1576,7 +1575,7 @@
           <p:cNvPr id="5" name="바닥글 개체 틀 4">
             <a:extLst>
               <a:ext uri="{FF2B5EF4-FFF2-40B4-BE49-F238E27FC236}">
-                <a16:creationId xmlns="" xmlns:a16="http://schemas.microsoft.com/office/drawing/2014/main" id="{AA45FF19-25D7-1FF3-E311-2C2E07B26764}"/>
+                <a16:creationId xmlns:a16="http://schemas.microsoft.com/office/drawing/2014/main" id="{AA45FF19-25D7-1FF3-E311-2C2E07B26764}"/>
               </a:ext>
             </a:extLst>
           </p:cNvPr>
@@ -1601,7 +1600,7 @@
           <p:cNvPr id="6" name="슬라이드 번호 개체 틀 5">
             <a:extLst>
               <a:ext uri="{FF2B5EF4-FFF2-40B4-BE49-F238E27FC236}">
-                <a16:creationId xmlns="" xmlns:a16="http://schemas.microsoft.com/office/drawing/2014/main" id="{6F43D8BF-52A4-97EB-612B-F9899664EFD5}"/>
+                <a16:creationId xmlns:a16="http://schemas.microsoft.com/office/drawing/2014/main" id="{6F43D8BF-52A4-97EB-612B-F9899664EFD5}"/>
               </a:ext>
             </a:extLst>
           </p:cNvPr>
@@ -1660,7 +1659,7 @@
           <p:cNvPr id="2" name="제목 1">
             <a:extLst>
               <a:ext uri="{FF2B5EF4-FFF2-40B4-BE49-F238E27FC236}">
-                <a16:creationId xmlns="" xmlns:a16="http://schemas.microsoft.com/office/drawing/2014/main" id="{1EB95909-78E9-5BAC-68EA-7DCA2A1271F7}"/>
+                <a16:creationId xmlns:a16="http://schemas.microsoft.com/office/drawing/2014/main" id="{1EB95909-78E9-5BAC-68EA-7DCA2A1271F7}"/>
               </a:ext>
             </a:extLst>
           </p:cNvPr>
@@ -1697,7 +1696,7 @@
           <p:cNvPr id="3" name="텍스트 개체 틀 2">
             <a:extLst>
               <a:ext uri="{FF2B5EF4-FFF2-40B4-BE49-F238E27FC236}">
-                <a16:creationId xmlns="" xmlns:a16="http://schemas.microsoft.com/office/drawing/2014/main" id="{D6B98DAF-2A47-3ECD-807C-96FB70CF9854}"/>
+                <a16:creationId xmlns:a16="http://schemas.microsoft.com/office/drawing/2014/main" id="{D6B98DAF-2A47-3ECD-807C-96FB70CF9854}"/>
               </a:ext>
             </a:extLst>
           </p:cNvPr>
@@ -1822,7 +1821,7 @@
           <p:cNvPr id="4" name="날짜 개체 틀 3">
             <a:extLst>
               <a:ext uri="{FF2B5EF4-FFF2-40B4-BE49-F238E27FC236}">
-                <a16:creationId xmlns="" xmlns:a16="http://schemas.microsoft.com/office/drawing/2014/main" id="{A3AD9670-C268-56FC-281A-FE1F59541EB9}"/>
+                <a16:creationId xmlns:a16="http://schemas.microsoft.com/office/drawing/2014/main" id="{A3AD9670-C268-56FC-281A-FE1F59541EB9}"/>
               </a:ext>
             </a:extLst>
           </p:cNvPr>
@@ -1851,7 +1850,7 @@
           <p:cNvPr id="5" name="바닥글 개체 틀 4">
             <a:extLst>
               <a:ext uri="{FF2B5EF4-FFF2-40B4-BE49-F238E27FC236}">
-                <a16:creationId xmlns="" xmlns:a16="http://schemas.microsoft.com/office/drawing/2014/main" id="{A4946F37-FE38-E38E-7339-DC6E4EFA5B3B}"/>
+                <a16:creationId xmlns:a16="http://schemas.microsoft.com/office/drawing/2014/main" id="{A4946F37-FE38-E38E-7339-DC6E4EFA5B3B}"/>
               </a:ext>
             </a:extLst>
           </p:cNvPr>
@@ -1876,7 +1875,7 @@
           <p:cNvPr id="6" name="슬라이드 번호 개체 틀 5">
             <a:extLst>
               <a:ext uri="{FF2B5EF4-FFF2-40B4-BE49-F238E27FC236}">
-                <a16:creationId xmlns="" xmlns:a16="http://schemas.microsoft.com/office/drawing/2014/main" id="{7C17C39B-6348-28CC-59AF-B1A65BE2F149}"/>
+                <a16:creationId xmlns:a16="http://schemas.microsoft.com/office/drawing/2014/main" id="{7C17C39B-6348-28CC-59AF-B1A65BE2F149}"/>
               </a:ext>
             </a:extLst>
           </p:cNvPr>
@@ -1935,7 +1934,7 @@
           <p:cNvPr id="2" name="제목 1">
             <a:extLst>
               <a:ext uri="{FF2B5EF4-FFF2-40B4-BE49-F238E27FC236}">
-                <a16:creationId xmlns="" xmlns:a16="http://schemas.microsoft.com/office/drawing/2014/main" id="{0D0EFA0F-10D7-865F-1370-4EA34C786709}"/>
+                <a16:creationId xmlns:a16="http://schemas.microsoft.com/office/drawing/2014/main" id="{0D0EFA0F-10D7-865F-1370-4EA34C786709}"/>
               </a:ext>
             </a:extLst>
           </p:cNvPr>
@@ -1963,7 +1962,7 @@
           <p:cNvPr id="3" name="내용 개체 틀 2">
             <a:extLst>
               <a:ext uri="{FF2B5EF4-FFF2-40B4-BE49-F238E27FC236}">
-                <a16:creationId xmlns="" xmlns:a16="http://schemas.microsoft.com/office/drawing/2014/main" id="{0498CDB5-9D2B-5F68-9DD8-ED20454B1044}"/>
+                <a16:creationId xmlns:a16="http://schemas.microsoft.com/office/drawing/2014/main" id="{0498CDB5-9D2B-5F68-9DD8-ED20454B1044}"/>
               </a:ext>
             </a:extLst>
           </p:cNvPr>
@@ -2025,7 +2024,7 @@
           <p:cNvPr id="4" name="내용 개체 틀 3">
             <a:extLst>
               <a:ext uri="{FF2B5EF4-FFF2-40B4-BE49-F238E27FC236}">
-                <a16:creationId xmlns="" xmlns:a16="http://schemas.microsoft.com/office/drawing/2014/main" id="{570EB1B7-8EDE-2794-EA53-E0C1972FAF1A}"/>
+                <a16:creationId xmlns:a16="http://schemas.microsoft.com/office/drawing/2014/main" id="{570EB1B7-8EDE-2794-EA53-E0C1972FAF1A}"/>
               </a:ext>
             </a:extLst>
           </p:cNvPr>
@@ -2087,7 +2086,7 @@
           <p:cNvPr id="5" name="날짜 개체 틀 4">
             <a:extLst>
               <a:ext uri="{FF2B5EF4-FFF2-40B4-BE49-F238E27FC236}">
-                <a16:creationId xmlns="" xmlns:a16="http://schemas.microsoft.com/office/drawing/2014/main" id="{31FBCFA4-CF51-706E-F9F0-8B66CA1A0E1B}"/>
+                <a16:creationId xmlns:a16="http://schemas.microsoft.com/office/drawing/2014/main" id="{31FBCFA4-CF51-706E-F9F0-8B66CA1A0E1B}"/>
               </a:ext>
             </a:extLst>
           </p:cNvPr>
@@ -2116,7 +2115,7 @@
           <p:cNvPr id="6" name="바닥글 개체 틀 5">
             <a:extLst>
               <a:ext uri="{FF2B5EF4-FFF2-40B4-BE49-F238E27FC236}">
-                <a16:creationId xmlns="" xmlns:a16="http://schemas.microsoft.com/office/drawing/2014/main" id="{FD56636A-469F-7FE9-480E-955BCC0E6D70}"/>
+                <a16:creationId xmlns:a16="http://schemas.microsoft.com/office/drawing/2014/main" id="{FD56636A-469F-7FE9-480E-955BCC0E6D70}"/>
               </a:ext>
             </a:extLst>
           </p:cNvPr>
@@ -2141,7 +2140,7 @@
           <p:cNvPr id="7" name="슬라이드 번호 개체 틀 6">
             <a:extLst>
               <a:ext uri="{FF2B5EF4-FFF2-40B4-BE49-F238E27FC236}">
-                <a16:creationId xmlns="" xmlns:a16="http://schemas.microsoft.com/office/drawing/2014/main" id="{3971D272-167D-EE36-E685-CD8BFE8CC9A6}"/>
+                <a16:creationId xmlns:a16="http://schemas.microsoft.com/office/drawing/2014/main" id="{3971D272-167D-EE36-E685-CD8BFE8CC9A6}"/>
               </a:ext>
             </a:extLst>
           </p:cNvPr>
@@ -2200,7 +2199,7 @@
           <p:cNvPr id="2" name="제목 1">
             <a:extLst>
               <a:ext uri="{FF2B5EF4-FFF2-40B4-BE49-F238E27FC236}">
-                <a16:creationId xmlns="" xmlns:a16="http://schemas.microsoft.com/office/drawing/2014/main" id="{9AC7230E-A2F3-4027-B6F6-9C5C289B1314}"/>
+                <a16:creationId xmlns:a16="http://schemas.microsoft.com/office/drawing/2014/main" id="{9AC7230E-A2F3-4027-B6F6-9C5C289B1314}"/>
               </a:ext>
             </a:extLst>
           </p:cNvPr>
@@ -2233,7 +2232,7 @@
           <p:cNvPr id="3" name="텍스트 개체 틀 2">
             <a:extLst>
               <a:ext uri="{FF2B5EF4-FFF2-40B4-BE49-F238E27FC236}">
-                <a16:creationId xmlns="" xmlns:a16="http://schemas.microsoft.com/office/drawing/2014/main" id="{0C685356-7419-AD93-377A-8D9A0293423E}"/>
+                <a16:creationId xmlns:a16="http://schemas.microsoft.com/office/drawing/2014/main" id="{0C685356-7419-AD93-377A-8D9A0293423E}"/>
               </a:ext>
             </a:extLst>
           </p:cNvPr>
@@ -2304,7 +2303,7 @@
           <p:cNvPr id="4" name="내용 개체 틀 3">
             <a:extLst>
               <a:ext uri="{FF2B5EF4-FFF2-40B4-BE49-F238E27FC236}">
-                <a16:creationId xmlns="" xmlns:a16="http://schemas.microsoft.com/office/drawing/2014/main" id="{CC36E6CA-94A6-3223-C91A-F6E9648C8EAD}"/>
+                <a16:creationId xmlns:a16="http://schemas.microsoft.com/office/drawing/2014/main" id="{CC36E6CA-94A6-3223-C91A-F6E9648C8EAD}"/>
               </a:ext>
             </a:extLst>
           </p:cNvPr>
@@ -2366,7 +2365,7 @@
           <p:cNvPr id="5" name="텍스트 개체 틀 4">
             <a:extLst>
               <a:ext uri="{FF2B5EF4-FFF2-40B4-BE49-F238E27FC236}">
-                <a16:creationId xmlns="" xmlns:a16="http://schemas.microsoft.com/office/drawing/2014/main" id="{F4DFD790-787A-88A3-300F-C173DAD2E1AF}"/>
+                <a16:creationId xmlns:a16="http://schemas.microsoft.com/office/drawing/2014/main" id="{F4DFD790-787A-88A3-300F-C173DAD2E1AF}"/>
               </a:ext>
             </a:extLst>
           </p:cNvPr>
@@ -2437,7 +2436,7 @@
           <p:cNvPr id="6" name="내용 개체 틀 5">
             <a:extLst>
               <a:ext uri="{FF2B5EF4-FFF2-40B4-BE49-F238E27FC236}">
-                <a16:creationId xmlns="" xmlns:a16="http://schemas.microsoft.com/office/drawing/2014/main" id="{012AE83D-2990-A6E4-CC9C-06D342A67C09}"/>
+                <a16:creationId xmlns:a16="http://schemas.microsoft.com/office/drawing/2014/main" id="{012AE83D-2990-A6E4-CC9C-06D342A67C09}"/>
               </a:ext>
             </a:extLst>
           </p:cNvPr>
@@ -2499,7 +2498,7 @@
           <p:cNvPr id="7" name="날짜 개체 틀 6">
             <a:extLst>
               <a:ext uri="{FF2B5EF4-FFF2-40B4-BE49-F238E27FC236}">
-                <a16:creationId xmlns="" xmlns:a16="http://schemas.microsoft.com/office/drawing/2014/main" id="{3C11F8C3-5AD3-730B-8ADB-304185DAA67E}"/>
+                <a16:creationId xmlns:a16="http://schemas.microsoft.com/office/drawing/2014/main" id="{3C11F8C3-5AD3-730B-8ADB-304185DAA67E}"/>
               </a:ext>
             </a:extLst>
           </p:cNvPr>
@@ -2528,7 +2527,7 @@
           <p:cNvPr id="8" name="바닥글 개체 틀 7">
             <a:extLst>
               <a:ext uri="{FF2B5EF4-FFF2-40B4-BE49-F238E27FC236}">
-                <a16:creationId xmlns="" xmlns:a16="http://schemas.microsoft.com/office/drawing/2014/main" id="{EF36ABA7-53C4-C11E-CC9D-F5E59BDBBD9B}"/>
+                <a16:creationId xmlns:a16="http://schemas.microsoft.com/office/drawing/2014/main" id="{EF36ABA7-53C4-C11E-CC9D-F5E59BDBBD9B}"/>
               </a:ext>
             </a:extLst>
           </p:cNvPr>
@@ -2553,7 +2552,7 @@
           <p:cNvPr id="9" name="슬라이드 번호 개체 틀 8">
             <a:extLst>
               <a:ext uri="{FF2B5EF4-FFF2-40B4-BE49-F238E27FC236}">
-                <a16:creationId xmlns="" xmlns:a16="http://schemas.microsoft.com/office/drawing/2014/main" id="{5E29E145-D4AE-F9FB-A218-47B323C43E03}"/>
+                <a16:creationId xmlns:a16="http://schemas.microsoft.com/office/drawing/2014/main" id="{5E29E145-D4AE-F9FB-A218-47B323C43E03}"/>
               </a:ext>
             </a:extLst>
           </p:cNvPr>
@@ -2612,7 +2611,7 @@
           <p:cNvPr id="2" name="제목 1">
             <a:extLst>
               <a:ext uri="{FF2B5EF4-FFF2-40B4-BE49-F238E27FC236}">
-                <a16:creationId xmlns="" xmlns:a16="http://schemas.microsoft.com/office/drawing/2014/main" id="{13D855E6-5AD7-B657-346A-38D87715A5E7}"/>
+                <a16:creationId xmlns:a16="http://schemas.microsoft.com/office/drawing/2014/main" id="{13D855E6-5AD7-B657-346A-38D87715A5E7}"/>
               </a:ext>
             </a:extLst>
           </p:cNvPr>
@@ -2640,7 +2639,7 @@
           <p:cNvPr id="3" name="날짜 개체 틀 2">
             <a:extLst>
               <a:ext uri="{FF2B5EF4-FFF2-40B4-BE49-F238E27FC236}">
-                <a16:creationId xmlns="" xmlns:a16="http://schemas.microsoft.com/office/drawing/2014/main" id="{F3052B06-09E1-1CD0-A032-AEB30F69A0E7}"/>
+                <a16:creationId xmlns:a16="http://schemas.microsoft.com/office/drawing/2014/main" id="{F3052B06-09E1-1CD0-A032-AEB30F69A0E7}"/>
               </a:ext>
             </a:extLst>
           </p:cNvPr>
@@ -2669,7 +2668,7 @@
           <p:cNvPr id="4" name="바닥글 개체 틀 3">
             <a:extLst>
               <a:ext uri="{FF2B5EF4-FFF2-40B4-BE49-F238E27FC236}">
-                <a16:creationId xmlns="" xmlns:a16="http://schemas.microsoft.com/office/drawing/2014/main" id="{DE18691A-8582-987D-DF06-E6D8B618E7BB}"/>
+                <a16:creationId xmlns:a16="http://schemas.microsoft.com/office/drawing/2014/main" id="{DE18691A-8582-987D-DF06-E6D8B618E7BB}"/>
               </a:ext>
             </a:extLst>
           </p:cNvPr>
@@ -2694,7 +2693,7 @@
           <p:cNvPr id="5" name="슬라이드 번호 개체 틀 4">
             <a:extLst>
               <a:ext uri="{FF2B5EF4-FFF2-40B4-BE49-F238E27FC236}">
-                <a16:creationId xmlns="" xmlns:a16="http://schemas.microsoft.com/office/drawing/2014/main" id="{6F997ACE-7D00-7B35-1F16-F56C5450EF85}"/>
+                <a16:creationId xmlns:a16="http://schemas.microsoft.com/office/drawing/2014/main" id="{6F997ACE-7D00-7B35-1F16-F56C5450EF85}"/>
               </a:ext>
             </a:extLst>
           </p:cNvPr>
@@ -2753,7 +2752,7 @@
           <p:cNvPr id="2" name="날짜 개체 틀 1">
             <a:extLst>
               <a:ext uri="{FF2B5EF4-FFF2-40B4-BE49-F238E27FC236}">
-                <a16:creationId xmlns="" xmlns:a16="http://schemas.microsoft.com/office/drawing/2014/main" id="{2703D88F-9D50-1761-731E-68DD1FC6B740}"/>
+                <a16:creationId xmlns:a16="http://schemas.microsoft.com/office/drawing/2014/main" id="{2703D88F-9D50-1761-731E-68DD1FC6B740}"/>
               </a:ext>
             </a:extLst>
           </p:cNvPr>
@@ -2782,7 +2781,7 @@
           <p:cNvPr id="3" name="바닥글 개체 틀 2">
             <a:extLst>
               <a:ext uri="{FF2B5EF4-FFF2-40B4-BE49-F238E27FC236}">
-                <a16:creationId xmlns="" xmlns:a16="http://schemas.microsoft.com/office/drawing/2014/main" id="{70793086-842E-7906-6019-4284A9E469F4}"/>
+                <a16:creationId xmlns:a16="http://schemas.microsoft.com/office/drawing/2014/main" id="{70793086-842E-7906-6019-4284A9E469F4}"/>
               </a:ext>
             </a:extLst>
           </p:cNvPr>
@@ -2807,7 +2806,7 @@
           <p:cNvPr id="4" name="슬라이드 번호 개체 틀 3">
             <a:extLst>
               <a:ext uri="{FF2B5EF4-FFF2-40B4-BE49-F238E27FC236}">
-                <a16:creationId xmlns="" xmlns:a16="http://schemas.microsoft.com/office/drawing/2014/main" id="{6D4FE3DE-7F26-4352-74EE-A720C7AF5564}"/>
+                <a16:creationId xmlns:a16="http://schemas.microsoft.com/office/drawing/2014/main" id="{6D4FE3DE-7F26-4352-74EE-A720C7AF5564}"/>
               </a:ext>
             </a:extLst>
           </p:cNvPr>
@@ -2866,7 +2865,7 @@
           <p:cNvPr id="2" name="제목 1">
             <a:extLst>
               <a:ext uri="{FF2B5EF4-FFF2-40B4-BE49-F238E27FC236}">
-                <a16:creationId xmlns="" xmlns:a16="http://schemas.microsoft.com/office/drawing/2014/main" id="{0AFB6F63-D5C7-EB4A-A651-8DA5561AD0DC}"/>
+                <a16:creationId xmlns:a16="http://schemas.microsoft.com/office/drawing/2014/main" id="{0AFB6F63-D5C7-EB4A-A651-8DA5561AD0DC}"/>
               </a:ext>
             </a:extLst>
           </p:cNvPr>
@@ -2903,7 +2902,7 @@
           <p:cNvPr id="3" name="내용 개체 틀 2">
             <a:extLst>
               <a:ext uri="{FF2B5EF4-FFF2-40B4-BE49-F238E27FC236}">
-                <a16:creationId xmlns="" xmlns:a16="http://schemas.microsoft.com/office/drawing/2014/main" id="{2000FB2D-0CF3-1A3C-E704-F8CA96C2D5D5}"/>
+                <a16:creationId xmlns:a16="http://schemas.microsoft.com/office/drawing/2014/main" id="{2000FB2D-0CF3-1A3C-E704-F8CA96C2D5D5}"/>
               </a:ext>
             </a:extLst>
           </p:cNvPr>
@@ -2993,7 +2992,7 @@
           <p:cNvPr id="4" name="텍스트 개체 틀 3">
             <a:extLst>
               <a:ext uri="{FF2B5EF4-FFF2-40B4-BE49-F238E27FC236}">
-                <a16:creationId xmlns="" xmlns:a16="http://schemas.microsoft.com/office/drawing/2014/main" id="{88C3C47D-E633-BB5D-0FA3-41A5E3C28A6A}"/>
+                <a16:creationId xmlns:a16="http://schemas.microsoft.com/office/drawing/2014/main" id="{88C3C47D-E633-BB5D-0FA3-41A5E3C28A6A}"/>
               </a:ext>
             </a:extLst>
           </p:cNvPr>
@@ -3064,7 +3063,7 @@
           <p:cNvPr id="5" name="날짜 개체 틀 4">
             <a:extLst>
               <a:ext uri="{FF2B5EF4-FFF2-40B4-BE49-F238E27FC236}">
-                <a16:creationId xmlns="" xmlns:a16="http://schemas.microsoft.com/office/drawing/2014/main" id="{603DA118-0D2F-73A1-6311-85E95462C569}"/>
+                <a16:creationId xmlns:a16="http://schemas.microsoft.com/office/drawing/2014/main" id="{603DA118-0D2F-73A1-6311-85E95462C569}"/>
               </a:ext>
             </a:extLst>
           </p:cNvPr>
@@ -3093,7 +3092,7 @@
           <p:cNvPr id="6" name="바닥글 개체 틀 5">
             <a:extLst>
               <a:ext uri="{FF2B5EF4-FFF2-40B4-BE49-F238E27FC236}">
-                <a16:creationId xmlns="" xmlns:a16="http://schemas.microsoft.com/office/drawing/2014/main" id="{DE46749A-348F-886F-32BD-A562F1A2A3B9}"/>
+                <a16:creationId xmlns:a16="http://schemas.microsoft.com/office/drawing/2014/main" id="{DE46749A-348F-886F-32BD-A562F1A2A3B9}"/>
               </a:ext>
             </a:extLst>
           </p:cNvPr>
@@ -3118,7 +3117,7 @@
           <p:cNvPr id="7" name="슬라이드 번호 개체 틀 6">
             <a:extLst>
               <a:ext uri="{FF2B5EF4-FFF2-40B4-BE49-F238E27FC236}">
-                <a16:creationId xmlns="" xmlns:a16="http://schemas.microsoft.com/office/drawing/2014/main" id="{0BF22D09-FBE9-294C-014E-9A808723A1A7}"/>
+                <a16:creationId xmlns:a16="http://schemas.microsoft.com/office/drawing/2014/main" id="{0BF22D09-FBE9-294C-014E-9A808723A1A7}"/>
               </a:ext>
             </a:extLst>
           </p:cNvPr>
@@ -3177,7 +3176,7 @@
           <p:cNvPr id="2" name="제목 1">
             <a:extLst>
               <a:ext uri="{FF2B5EF4-FFF2-40B4-BE49-F238E27FC236}">
-                <a16:creationId xmlns="" xmlns:a16="http://schemas.microsoft.com/office/drawing/2014/main" id="{DA50C132-3A30-7E9C-0BBB-1CD1A789CE68}"/>
+                <a16:creationId xmlns:a16="http://schemas.microsoft.com/office/drawing/2014/main" id="{DA50C132-3A30-7E9C-0BBB-1CD1A789CE68}"/>
               </a:ext>
             </a:extLst>
           </p:cNvPr>
@@ -3214,7 +3213,7 @@
           <p:cNvPr id="3" name="그림 개체 틀 2">
             <a:extLst>
               <a:ext uri="{FF2B5EF4-FFF2-40B4-BE49-F238E27FC236}">
-                <a16:creationId xmlns="" xmlns:a16="http://schemas.microsoft.com/office/drawing/2014/main" id="{2F31776A-D32D-34F5-8A99-A26F4F6535B9}"/>
+                <a16:creationId xmlns:a16="http://schemas.microsoft.com/office/drawing/2014/main" id="{2F31776A-D32D-34F5-8A99-A26F4F6535B9}"/>
               </a:ext>
             </a:extLst>
           </p:cNvPr>
@@ -3281,7 +3280,7 @@
           <p:cNvPr id="4" name="텍스트 개체 틀 3">
             <a:extLst>
               <a:ext uri="{FF2B5EF4-FFF2-40B4-BE49-F238E27FC236}">
-                <a16:creationId xmlns="" xmlns:a16="http://schemas.microsoft.com/office/drawing/2014/main" id="{3E500BF3-C366-20F6-6257-8233A0794521}"/>
+                <a16:creationId xmlns:a16="http://schemas.microsoft.com/office/drawing/2014/main" id="{3E500BF3-C366-20F6-6257-8233A0794521}"/>
               </a:ext>
             </a:extLst>
           </p:cNvPr>
@@ -3352,7 +3351,7 @@
           <p:cNvPr id="5" name="날짜 개체 틀 4">
             <a:extLst>
               <a:ext uri="{FF2B5EF4-FFF2-40B4-BE49-F238E27FC236}">
-                <a16:creationId xmlns="" xmlns:a16="http://schemas.microsoft.com/office/drawing/2014/main" id="{DB1C119C-B590-D055-6B10-AAE861F0D2B1}"/>
+                <a16:creationId xmlns:a16="http://schemas.microsoft.com/office/drawing/2014/main" id="{DB1C119C-B590-D055-6B10-AAE861F0D2B1}"/>
               </a:ext>
             </a:extLst>
           </p:cNvPr>
@@ -3381,7 +3380,7 @@
           <p:cNvPr id="6" name="바닥글 개체 틀 5">
             <a:extLst>
               <a:ext uri="{FF2B5EF4-FFF2-40B4-BE49-F238E27FC236}">
-                <a16:creationId xmlns="" xmlns:a16="http://schemas.microsoft.com/office/drawing/2014/main" id="{00064F92-4550-973E-464E-89CA3E7EED4F}"/>
+                <a16:creationId xmlns:a16="http://schemas.microsoft.com/office/drawing/2014/main" id="{00064F92-4550-973E-464E-89CA3E7EED4F}"/>
               </a:ext>
             </a:extLst>
           </p:cNvPr>
@@ -3406,7 +3405,7 @@
           <p:cNvPr id="7" name="슬라이드 번호 개체 틀 6">
             <a:extLst>
               <a:ext uri="{FF2B5EF4-FFF2-40B4-BE49-F238E27FC236}">
-                <a16:creationId xmlns="" xmlns:a16="http://schemas.microsoft.com/office/drawing/2014/main" id="{708384D1-792D-8EA8-718E-F756CEE623A7}"/>
+                <a16:creationId xmlns:a16="http://schemas.microsoft.com/office/drawing/2014/main" id="{708384D1-792D-8EA8-718E-F756CEE623A7}"/>
               </a:ext>
             </a:extLst>
           </p:cNvPr>
@@ -3470,7 +3469,7 @@
           <p:cNvPr id="2" name="제목 개체 틀 1">
             <a:extLst>
               <a:ext uri="{FF2B5EF4-FFF2-40B4-BE49-F238E27FC236}">
-                <a16:creationId xmlns="" xmlns:a16="http://schemas.microsoft.com/office/drawing/2014/main" id="{C0AC0570-6E75-D8C0-582D-3A448969CF8B}"/>
+                <a16:creationId xmlns:a16="http://schemas.microsoft.com/office/drawing/2014/main" id="{C0AC0570-6E75-D8C0-582D-3A448969CF8B}"/>
               </a:ext>
             </a:extLst>
           </p:cNvPr>
@@ -3508,7 +3507,7 @@
           <p:cNvPr id="3" name="텍스트 개체 틀 2">
             <a:extLst>
               <a:ext uri="{FF2B5EF4-FFF2-40B4-BE49-F238E27FC236}">
-                <a16:creationId xmlns="" xmlns:a16="http://schemas.microsoft.com/office/drawing/2014/main" id="{79ADFDDF-DF3C-19FA-0ED8-5D640C08DB4B}"/>
+                <a16:creationId xmlns:a16="http://schemas.microsoft.com/office/drawing/2014/main" id="{79ADFDDF-DF3C-19FA-0ED8-5D640C08DB4B}"/>
               </a:ext>
             </a:extLst>
           </p:cNvPr>
@@ -3575,7 +3574,7 @@
           <p:cNvPr id="4" name="날짜 개체 틀 3">
             <a:extLst>
               <a:ext uri="{FF2B5EF4-FFF2-40B4-BE49-F238E27FC236}">
-                <a16:creationId xmlns="" xmlns:a16="http://schemas.microsoft.com/office/drawing/2014/main" id="{AB9AC677-7913-29B2-30F7-969771FA5D05}"/>
+                <a16:creationId xmlns:a16="http://schemas.microsoft.com/office/drawing/2014/main" id="{AB9AC677-7913-29B2-30F7-969771FA5D05}"/>
               </a:ext>
             </a:extLst>
           </p:cNvPr>
@@ -3622,7 +3621,7 @@
           <p:cNvPr id="5" name="바닥글 개체 틀 4">
             <a:extLst>
               <a:ext uri="{FF2B5EF4-FFF2-40B4-BE49-F238E27FC236}">
-                <a16:creationId xmlns="" xmlns:a16="http://schemas.microsoft.com/office/drawing/2014/main" id="{3A6836E4-21B2-245A-8933-7F64F64AC382}"/>
+                <a16:creationId xmlns:a16="http://schemas.microsoft.com/office/drawing/2014/main" id="{3A6836E4-21B2-245A-8933-7F64F64AC382}"/>
               </a:ext>
             </a:extLst>
           </p:cNvPr>
@@ -3665,7 +3664,7 @@
           <p:cNvPr id="6" name="슬라이드 번호 개체 틀 5">
             <a:extLst>
               <a:ext uri="{FF2B5EF4-FFF2-40B4-BE49-F238E27FC236}">
-                <a16:creationId xmlns="" xmlns:a16="http://schemas.microsoft.com/office/drawing/2014/main" id="{6F2D0B4E-8F0D-F1B8-2A71-9862FC9749C5}"/>
+                <a16:creationId xmlns:a16="http://schemas.microsoft.com/office/drawing/2014/main" id="{6F2D0B4E-8F0D-F1B8-2A71-9862FC9749C5}"/>
               </a:ext>
             </a:extLst>
           </p:cNvPr>
@@ -4033,7 +4032,7 @@
           <p:cNvPr id="4" name="TextBox 3">
             <a:extLst>
               <a:ext uri="{FF2B5EF4-FFF2-40B4-BE49-F238E27FC236}">
-                <a16:creationId xmlns="" xmlns:a16="http://schemas.microsoft.com/office/drawing/2014/main" id="{793E08CF-A6B7-6BE9-B7B8-4498ADC66316}"/>
+                <a16:creationId xmlns:a16="http://schemas.microsoft.com/office/drawing/2014/main" id="{793E08CF-A6B7-6BE9-B7B8-4498ADC66316}"/>
               </a:ext>
             </a:extLst>
           </p:cNvPr>
@@ -4065,41 +4064,40 @@
               <a:t>: </a:t>
             </a:r>
             <a:r>
-              <a:rPr lang="ko-KR" altLang="en-US" sz="2400" dirty="0" smtClean="0"/>
+              <a:rPr lang="ko-KR" altLang="en-US" sz="2400" dirty="0"/>
               <a:t>캐릭터 애니메이션 </a:t>
             </a:r>
             <a:r>
-              <a:rPr lang="ko-KR" altLang="en-US" sz="2400" dirty="0" err="1" smtClean="0"/>
+              <a:rPr lang="ko-KR" altLang="en-US" sz="2400" dirty="0" err="1"/>
               <a:t>파쿠르</a:t>
             </a:r>
             <a:r>
-              <a:rPr lang="ko-KR" altLang="en-US" sz="2400" dirty="0" smtClean="0"/>
+              <a:rPr lang="ko-KR" altLang="en-US" sz="2400" dirty="0"/>
               <a:t> 시스템 </a:t>
             </a:r>
             <a:r>
-              <a:rPr lang="en-US" altLang="ko-KR" sz="2400" dirty="0" smtClean="0"/>
+              <a:rPr lang="en-US" altLang="ko-KR" sz="2400" dirty="0"/>
               <a:t>1</a:t>
             </a:r>
             <a:r>
-              <a:rPr lang="ko-KR" altLang="en-US" sz="2400" dirty="0" smtClean="0"/>
+              <a:rPr lang="ko-KR" altLang="en-US" sz="2400" dirty="0"/>
               <a:t>주차</a:t>
             </a:r>
-            <a:endParaRPr lang="en-US" altLang="ko-KR" sz="2400" dirty="0" smtClean="0"/>
-          </a:p>
-          <a:p>
-            <a:r>
-              <a:rPr lang="ko-KR" altLang="en-US" dirty="0" smtClean="0"/>
+            <a:endParaRPr lang="en-US" altLang="ko-KR" sz="2400" dirty="0"/>
+          </a:p>
+          <a:p>
+            <a:r>
+              <a:rPr lang="ko-KR" altLang="en-US" dirty="0"/>
               <a:t>발표자 </a:t>
             </a:r>
             <a:r>
-              <a:rPr lang="en-US" altLang="ko-KR" dirty="0" smtClean="0"/>
+              <a:rPr lang="en-US" altLang="ko-KR" dirty="0"/>
               <a:t>: </a:t>
             </a:r>
             <a:r>
-              <a:rPr lang="ko-KR" altLang="en-US" dirty="0" smtClean="0"/>
+              <a:rPr lang="ko-KR" altLang="en-US" dirty="0"/>
               <a:t>김정환</a:t>
             </a:r>
-            <a:endParaRPr lang="ko-KR" altLang="en-US" dirty="0"/>
           </a:p>
         </p:txBody>
       </p:sp>
@@ -4124,7 +4122,7 @@
         <p:cNvPr id="1" name="">
           <a:extLst>
             <a:ext uri="{FF2B5EF4-FFF2-40B4-BE49-F238E27FC236}">
-              <a16:creationId xmlns="" xmlns:a16="http://schemas.microsoft.com/office/drawing/2014/main" id="{068E24C7-A429-CDA0-4EB6-16142BB05552}"/>
+              <a16:creationId xmlns:a16="http://schemas.microsoft.com/office/drawing/2014/main" id="{068E24C7-A429-CDA0-4EB6-16142BB05552}"/>
             </a:ext>
           </a:extLst>
         </p:cNvPr>
@@ -4144,7 +4142,7 @@
           <p:cNvPr id="5" name="TextBox 4">
             <a:extLst>
               <a:ext uri="{FF2B5EF4-FFF2-40B4-BE49-F238E27FC236}">
-                <a16:creationId xmlns="" xmlns:a16="http://schemas.microsoft.com/office/drawing/2014/main" id="{4715F932-2F2C-4A3F-7F16-1B13D352985A}"/>
+                <a16:creationId xmlns:a16="http://schemas.microsoft.com/office/drawing/2014/main" id="{4715F932-2F2C-4A3F-7F16-1B13D352985A}"/>
               </a:ext>
             </a:extLst>
           </p:cNvPr>
@@ -4180,7 +4178,7 @@
           <p:cNvPr id="6" name="TextBox 5">
             <a:extLst>
               <a:ext uri="{FF2B5EF4-FFF2-40B4-BE49-F238E27FC236}">
-                <a16:creationId xmlns="" xmlns:a16="http://schemas.microsoft.com/office/drawing/2014/main" id="{6DE5C835-CE30-2461-B5B2-C304088E694A}"/>
+                <a16:creationId xmlns:a16="http://schemas.microsoft.com/office/drawing/2014/main" id="{6DE5C835-CE30-2461-B5B2-C304088E694A}"/>
               </a:ext>
             </a:extLst>
           </p:cNvPr>
@@ -4208,10 +4206,10 @@
               <a:buChar char="•"/>
             </a:pPr>
             <a:r>
-              <a:rPr lang="ko-KR" altLang="en-US" sz="1600" dirty="0" smtClean="0"/>
+              <a:rPr lang="ko-KR" altLang="en-US" sz="1600" dirty="0"/>
               <a:t>미니엔진 구성 파악</a:t>
             </a:r>
-            <a:endParaRPr lang="en-US" altLang="ko-KR" sz="1600" dirty="0" smtClean="0"/>
+            <a:endParaRPr lang="en-US" altLang="ko-KR" sz="1600" dirty="0"/>
           </a:p>
           <a:p>
             <a:pPr marL="742950" lvl="1" indent="-285750">
@@ -4220,11 +4218,7 @@
             </a:pPr>
             <a:r>
               <a:rPr lang="en-US" altLang="ko-KR" sz="1600" dirty="0"/>
-              <a:t>https://</a:t>
-            </a:r>
-            <a:r>
-              <a:rPr lang="en-US" altLang="ko-KR" sz="1600" dirty="0" smtClean="0"/>
-              <a:t>github.com/microsoft/DirectX-Graphics-Samples</a:t>
+              <a:t>https://github.com/microsoft/DirectX-Graphics-Samples</a:t>
             </a:r>
           </a:p>
         </p:txBody>
@@ -4271,7 +4265,7 @@
           <a:p>
             <a:pPr algn="ctr"/>
             <a:r>
-              <a:rPr lang="en-US" altLang="ko-KR" sz="1400" dirty="0" smtClean="0">
+              <a:rPr lang="en-US" altLang="ko-KR" sz="1400" dirty="0">
                 <a:solidFill>
                   <a:schemeClr val="bg1"/>
                 </a:solidFill>
@@ -4326,7 +4320,7 @@
           <a:p>
             <a:pPr algn="ctr"/>
             <a:r>
-              <a:rPr lang="en-US" altLang="ko-KR" sz="1400" dirty="0" err="1" smtClean="0">
+              <a:rPr lang="en-US" altLang="ko-KR" sz="1400" dirty="0" err="1">
                 <a:solidFill>
                   <a:schemeClr val="tx1"/>
                 </a:solidFill>
@@ -4383,7 +4377,7 @@
           <a:p>
             <a:pPr algn="ctr"/>
             <a:r>
-              <a:rPr lang="en-US" altLang="ko-KR" sz="1400" dirty="0" err="1" smtClean="0">
+              <a:rPr lang="en-US" altLang="ko-KR" sz="1400" dirty="0" err="1">
                 <a:solidFill>
                   <a:schemeClr val="bg1"/>
                 </a:solidFill>
@@ -4459,10 +4453,9 @@
           <a:lstStyle/>
           <a:p>
             <a:r>
-              <a:rPr lang="ko-KR" altLang="en-US" sz="1500" dirty="0" smtClean="0"/>
+              <a:rPr lang="ko-KR" altLang="en-US" sz="1500" dirty="0"/>
               <a:t>구현</a:t>
             </a:r>
-            <a:endParaRPr lang="ko-KR" altLang="en-US" sz="1500" dirty="0"/>
           </a:p>
         </p:txBody>
       </p:sp>
@@ -4489,29 +4482,24 @@
           <a:lstStyle/>
           <a:p>
             <a:r>
-              <a:rPr lang="en-US" altLang="ko-KR" sz="1500" dirty="0" err="1" smtClean="0"/>
+              <a:rPr lang="en-US" altLang="ko-KR" sz="1500" dirty="0" err="1"/>
               <a:t>GameApp</a:t>
             </a:r>
             <a:r>
-              <a:rPr lang="en-US" altLang="ko-KR" sz="1500" dirty="0" smtClean="0"/>
+              <a:rPr lang="en-US" altLang="ko-KR" sz="1500" dirty="0"/>
               <a:t> </a:t>
             </a:r>
             <a:r>
-              <a:rPr lang="ko-KR" altLang="en-US" sz="1500" dirty="0" smtClean="0"/>
+              <a:rPr lang="ko-KR" altLang="en-US" sz="1500" dirty="0"/>
               <a:t>구현 </a:t>
             </a:r>
-            <a:r>
-              <a:rPr lang="en-US" altLang="ko-KR" sz="1500" dirty="0" smtClean="0"/>
-              <a:t/>
-            </a:r>
             <a:br>
-              <a:rPr lang="en-US" altLang="ko-KR" sz="1500" dirty="0" smtClean="0"/>
+              <a:rPr lang="en-US" altLang="ko-KR" sz="1500" dirty="0"/>
             </a:br>
             <a:r>
-              <a:rPr lang="ko-KR" altLang="en-US" sz="1500" dirty="0" smtClean="0"/>
+              <a:rPr lang="ko-KR" altLang="en-US" sz="1500" dirty="0"/>
               <a:t>예시 프로젝트</a:t>
             </a:r>
-            <a:endParaRPr lang="ko-KR" altLang="en-US" sz="1500" dirty="0"/>
           </a:p>
         </p:txBody>
       </p:sp>
@@ -4538,25 +4526,20 @@
           <a:lstStyle/>
           <a:p>
             <a:r>
-              <a:rPr lang="en-US" altLang="ko-KR" sz="1500" dirty="0" smtClean="0"/>
+              <a:rPr lang="en-US" altLang="ko-KR" sz="1500" dirty="0"/>
               <a:t>DirectX12 </a:t>
             </a:r>
             <a:r>
-              <a:rPr lang="ko-KR" altLang="en-US" sz="1500" dirty="0" smtClean="0"/>
+              <a:rPr lang="ko-KR" altLang="en-US" sz="1500" dirty="0"/>
               <a:t>및 엔진 구현</a:t>
             </a:r>
-            <a:r>
-              <a:rPr lang="en-US" altLang="ko-KR" sz="1500" dirty="0" smtClean="0"/>
-              <a:t/>
-            </a:r>
             <a:br>
-              <a:rPr lang="en-US" altLang="ko-KR" sz="1500" dirty="0" smtClean="0"/>
+              <a:rPr lang="en-US" altLang="ko-KR" sz="1500" dirty="0"/>
             </a:br>
             <a:r>
-              <a:rPr lang="ko-KR" altLang="en-US" sz="1500" dirty="0" smtClean="0"/>
+              <a:rPr lang="ko-KR" altLang="en-US" sz="1500" dirty="0"/>
               <a:t>정적 라이브러리</a:t>
             </a:r>
-            <a:endParaRPr lang="ko-KR" altLang="en-US" sz="1500" dirty="0"/>
           </a:p>
         </p:txBody>
       </p:sp>
@@ -4602,7 +4585,7 @@
           <a:p>
             <a:pPr algn="ctr"/>
             <a:r>
-              <a:rPr lang="en-US" altLang="ko-KR" sz="1400" dirty="0" smtClean="0">
+              <a:rPr lang="en-US" altLang="ko-KR" sz="1400" dirty="0">
                 <a:solidFill>
                   <a:schemeClr val="bg1"/>
                 </a:solidFill>
@@ -4640,25 +4623,24 @@
           <a:lstStyle/>
           <a:p>
             <a:r>
-              <a:rPr lang="ko-KR" altLang="en-US" sz="1500" dirty="0" smtClean="0"/>
+              <a:rPr lang="ko-KR" altLang="en-US" sz="1500" dirty="0"/>
               <a:t>모델 </a:t>
             </a:r>
             <a:r>
-              <a:rPr lang="ko-KR" altLang="en-US" sz="1500" dirty="0" err="1" smtClean="0"/>
+              <a:rPr lang="ko-KR" altLang="en-US" sz="1500" dirty="0" err="1"/>
               <a:t>렌더링</a:t>
             </a:r>
             <a:r>
-              <a:rPr lang="ko-KR" altLang="en-US" sz="1500" dirty="0" smtClean="0"/>
+              <a:rPr lang="ko-KR" altLang="en-US" sz="1500" dirty="0"/>
               <a:t> 구현 예시</a:t>
             </a:r>
-            <a:endParaRPr lang="en-US" altLang="ko-KR" sz="1500" dirty="0" smtClean="0"/>
-          </a:p>
-          <a:p>
-            <a:r>
-              <a:rPr lang="ko-KR" altLang="en-US" sz="1500" dirty="0" smtClean="0"/>
+            <a:endParaRPr lang="en-US" altLang="ko-KR" sz="1500" dirty="0"/>
+          </a:p>
+          <a:p>
+            <a:r>
+              <a:rPr lang="ko-KR" altLang="en-US" sz="1500" dirty="0"/>
               <a:t>정적 라이브러리</a:t>
             </a:r>
-            <a:endParaRPr lang="ko-KR" altLang="en-US" sz="1500" dirty="0"/>
           </a:p>
         </p:txBody>
       </p:sp>
@@ -4721,21 +4703,16 @@
           <a:lstStyle/>
           <a:p>
             <a:r>
-              <a:rPr lang="ko-KR" altLang="en-US" sz="1500" dirty="0" smtClean="0"/>
+              <a:rPr lang="ko-KR" altLang="en-US" sz="1500" dirty="0"/>
               <a:t>엔진 게임루프 구현 </a:t>
             </a:r>
-            <a:r>
-              <a:rPr lang="en-US" altLang="ko-KR" sz="1500" dirty="0" smtClean="0"/>
-              <a:t/>
-            </a:r>
             <a:br>
-              <a:rPr lang="en-US" altLang="ko-KR" sz="1500" dirty="0" smtClean="0"/>
+              <a:rPr lang="en-US" altLang="ko-KR" sz="1500" dirty="0"/>
             </a:br>
             <a:r>
-              <a:rPr lang="ko-KR" altLang="en-US" sz="1500" dirty="0" smtClean="0"/>
+              <a:rPr lang="ko-KR" altLang="en-US" sz="1500" dirty="0"/>
               <a:t>인터페이스</a:t>
             </a:r>
-            <a:endParaRPr lang="ko-KR" altLang="en-US" sz="1500" dirty="0"/>
           </a:p>
         </p:txBody>
       </p:sp>
@@ -4799,23 +4776,23 @@
           <a:p>
             <a:pPr algn="ctr"/>
             <a:r>
-              <a:rPr lang="en-US" altLang="ko-KR" sz="1500" dirty="0" smtClean="0"/>
+              <a:rPr lang="en-US" altLang="ko-KR" sz="1500" dirty="0"/>
               <a:t>DirectX12 </a:t>
             </a:r>
             <a:r>
-              <a:rPr lang="ko-KR" altLang="en-US" sz="1500" dirty="0" smtClean="0"/>
+              <a:rPr lang="ko-KR" altLang="en-US" sz="1500" dirty="0"/>
               <a:t>이용</a:t>
             </a:r>
-            <a:endParaRPr lang="en-US" altLang="ko-KR" sz="1500" dirty="0" smtClean="0"/>
+            <a:endParaRPr lang="en-US" altLang="ko-KR" sz="1500" dirty="0"/>
           </a:p>
           <a:p>
             <a:pPr algn="ctr"/>
             <a:r>
-              <a:rPr lang="ko-KR" altLang="en-US" sz="1500" dirty="0" smtClean="0"/>
+              <a:rPr lang="ko-KR" altLang="en-US" sz="1500" dirty="0"/>
               <a:t>모델 </a:t>
             </a:r>
             <a:r>
-              <a:rPr lang="ko-KR" altLang="en-US" sz="1500" dirty="0" err="1" smtClean="0"/>
+              <a:rPr lang="ko-KR" altLang="en-US" sz="1500" dirty="0" err="1"/>
               <a:t>렌더링</a:t>
             </a:r>
             <a:endParaRPr lang="ko-KR" altLang="en-US" sz="1500" dirty="0"/>
@@ -4846,11 +4823,11 @@
           <a:p>
             <a:pPr algn="ctr"/>
             <a:r>
-              <a:rPr lang="ko-KR" altLang="en-US" sz="1500" dirty="0" smtClean="0"/>
+              <a:rPr lang="ko-KR" altLang="en-US" sz="1500" dirty="0"/>
               <a:t>모델 </a:t>
             </a:r>
             <a:r>
-              <a:rPr lang="ko-KR" altLang="en-US" sz="1500" dirty="0" err="1" smtClean="0"/>
+              <a:rPr lang="ko-KR" altLang="en-US" sz="1500" dirty="0" err="1"/>
               <a:t>렌더링</a:t>
             </a:r>
             <a:endParaRPr lang="ko-KR" altLang="en-US" sz="1500" dirty="0"/>
@@ -4899,7 +4876,7 @@
           <a:p>
             <a:pPr algn="ctr"/>
             <a:r>
-              <a:rPr lang="en-US" altLang="ko-KR" sz="1400" dirty="0" err="1" smtClean="0">
+              <a:rPr lang="en-US" altLang="ko-KR" sz="1400" dirty="0" err="1">
                 <a:solidFill>
                   <a:schemeClr val="bg1"/>
                 </a:solidFill>
@@ -4972,57 +4949,57 @@
           <a:lstStyle/>
           <a:p>
             <a:r>
-              <a:rPr lang="ko-KR" altLang="en-US" sz="1500" dirty="0" smtClean="0"/>
+              <a:rPr lang="ko-KR" altLang="en-US" sz="1500" dirty="0"/>
               <a:t>사전</a:t>
             </a:r>
             <a:r>
-              <a:rPr lang="en-US" altLang="ko-KR" sz="1500" dirty="0" smtClean="0"/>
+              <a:rPr lang="en-US" altLang="ko-KR" sz="1500" dirty="0"/>
               <a:t>, 3d </a:t>
             </a:r>
             <a:r>
-              <a:rPr lang="ko-KR" altLang="en-US" sz="1500" dirty="0" smtClean="0"/>
+              <a:rPr lang="ko-KR" altLang="en-US" sz="1500" dirty="0"/>
               <a:t>파일 </a:t>
             </a:r>
             <a:r>
-              <a:rPr lang="ko-KR" altLang="en-US" sz="1500" dirty="0" err="1" smtClean="0"/>
+              <a:rPr lang="ko-KR" altLang="en-US" sz="1500" dirty="0" err="1"/>
               <a:t>파싱</a:t>
             </a:r>
             <a:r>
-              <a:rPr lang="ko-KR" altLang="en-US" sz="1500" dirty="0" smtClean="0"/>
+              <a:rPr lang="ko-KR" altLang="en-US" sz="1500" dirty="0"/>
               <a:t> 및 최적화 프로젝트</a:t>
             </a:r>
-            <a:endParaRPr lang="en-US" altLang="ko-KR" sz="1500" dirty="0" smtClean="0"/>
-          </a:p>
-          <a:p>
-            <a:r>
-              <a:rPr lang="en-US" altLang="ko-KR" sz="1500" dirty="0" smtClean="0"/>
+            <a:endParaRPr lang="en-US" altLang="ko-KR" sz="1500" dirty="0"/>
+          </a:p>
+          <a:p>
+            <a:r>
+              <a:rPr lang="en-US" altLang="ko-KR" sz="1500" dirty="0"/>
               <a:t>.</a:t>
             </a:r>
             <a:r>
-              <a:rPr lang="en-US" altLang="ko-KR" sz="1500" dirty="0" err="1" smtClean="0"/>
+              <a:rPr lang="en-US" altLang="ko-KR" sz="1500" dirty="0" err="1"/>
               <a:t>obj</a:t>
             </a:r>
             <a:r>
-              <a:rPr lang="en-US" altLang="ko-KR" sz="1500" dirty="0" smtClean="0"/>
+              <a:rPr lang="en-US" altLang="ko-KR" sz="1500" dirty="0"/>
               <a:t>, .</a:t>
             </a:r>
             <a:r>
-              <a:rPr lang="en-US" altLang="ko-KR" sz="1500" dirty="0" err="1" smtClean="0"/>
+              <a:rPr lang="en-US" altLang="ko-KR" sz="1500" dirty="0" err="1"/>
               <a:t>gltf</a:t>
             </a:r>
             <a:r>
-              <a:rPr lang="en-US" altLang="ko-KR" sz="1500" dirty="0" smtClean="0"/>
+              <a:rPr lang="en-US" altLang="ko-KR" sz="1500" dirty="0"/>
               <a:t> </a:t>
             </a:r>
             <a:r>
-              <a:rPr lang="ko-KR" altLang="en-US" sz="1500" dirty="0" err="1" smtClean="0"/>
+              <a:rPr lang="ko-KR" altLang="en-US" sz="1500" dirty="0" err="1"/>
               <a:t>확장자</a:t>
             </a:r>
             <a:r>
-              <a:rPr lang="ko-KR" altLang="en-US" sz="1500" dirty="0" smtClean="0"/>
+              <a:rPr lang="ko-KR" altLang="en-US" sz="1500" dirty="0"/>
               <a:t> 변환 예시</a:t>
             </a:r>
-            <a:endParaRPr lang="en-US" altLang="ko-KR" sz="1500" dirty="0" smtClean="0"/>
+            <a:endParaRPr lang="en-US" altLang="ko-KR" sz="1500" dirty="0"/>
           </a:p>
         </p:txBody>
       </p:sp>
@@ -5070,10 +5047,9 @@
               <a:t> </a:t>
             </a:r>
             <a:r>
-              <a:rPr lang="ko-KR" altLang="en-US" sz="1500" dirty="0" smtClean="0"/>
+              <a:rPr lang="ko-KR" altLang="en-US" sz="1500" dirty="0"/>
               <a:t>파일 변환</a:t>
             </a:r>
-            <a:endParaRPr lang="ko-KR" altLang="en-US" sz="1500" dirty="0"/>
           </a:p>
         </p:txBody>
       </p:sp>
@@ -5098,7 +5074,7 @@
         <p:cNvPr id="1" name="">
           <a:extLst>
             <a:ext uri="{FF2B5EF4-FFF2-40B4-BE49-F238E27FC236}">
-              <a16:creationId xmlns="" xmlns:a16="http://schemas.microsoft.com/office/drawing/2014/main" id="{068E24C7-A429-CDA0-4EB6-16142BB05552}"/>
+              <a16:creationId xmlns:a16="http://schemas.microsoft.com/office/drawing/2014/main" id="{068E24C7-A429-CDA0-4EB6-16142BB05552}"/>
             </a:ext>
           </a:extLst>
         </p:cNvPr>
@@ -5118,7 +5094,7 @@
           <p:cNvPr id="5" name="TextBox 4">
             <a:extLst>
               <a:ext uri="{FF2B5EF4-FFF2-40B4-BE49-F238E27FC236}">
-                <a16:creationId xmlns="" xmlns:a16="http://schemas.microsoft.com/office/drawing/2014/main" id="{4715F932-2F2C-4A3F-7F16-1B13D352985A}"/>
+                <a16:creationId xmlns:a16="http://schemas.microsoft.com/office/drawing/2014/main" id="{4715F932-2F2C-4A3F-7F16-1B13D352985A}"/>
               </a:ext>
             </a:extLst>
           </p:cNvPr>
@@ -5154,7 +5130,7 @@
           <p:cNvPr id="6" name="TextBox 5">
             <a:extLst>
               <a:ext uri="{FF2B5EF4-FFF2-40B4-BE49-F238E27FC236}">
-                <a16:creationId xmlns="" xmlns:a16="http://schemas.microsoft.com/office/drawing/2014/main" id="{6DE5C835-CE30-2461-B5B2-C304088E694A}"/>
+                <a16:creationId xmlns:a16="http://schemas.microsoft.com/office/drawing/2014/main" id="{6DE5C835-CE30-2461-B5B2-C304088E694A}"/>
               </a:ext>
             </a:extLst>
           </p:cNvPr>
@@ -5183,19 +5159,7 @@
             </a:pPr>
             <a:r>
               <a:rPr lang="ko-KR" altLang="en-US" sz="1600" dirty="0"/>
-              <a:t>엔진 </a:t>
-            </a:r>
-            <a:r>
-              <a:rPr lang="ko-KR" altLang="en-US" sz="1600" dirty="0" smtClean="0"/>
-              <a:t>기반 </a:t>
-            </a:r>
-            <a:r>
-              <a:rPr lang="ko-KR" altLang="en-US" sz="1600" dirty="0"/>
-              <a:t>클래스 </a:t>
-            </a:r>
-            <a:r>
-              <a:rPr lang="ko-KR" altLang="en-US" sz="1600" dirty="0" smtClean="0"/>
-              <a:t>작성</a:t>
+              <a:t>엔진 기반 클래스 작성</a:t>
             </a:r>
             <a:endParaRPr lang="en-US" altLang="ko-KR" sz="1600" dirty="0"/>
           </a:p>
@@ -5241,7 +5205,7 @@
           <a:p>
             <a:pPr algn="ctr"/>
             <a:r>
-              <a:rPr lang="en-US" altLang="ko-KR" sz="1400" dirty="0" err="1" smtClean="0">
+              <a:rPr lang="en-US" altLang="ko-KR" sz="1400" dirty="0" err="1">
                 <a:solidFill>
                   <a:schemeClr val="tx1"/>
                 </a:solidFill>
@@ -5298,7 +5262,7 @@
           <a:p>
             <a:pPr algn="ctr"/>
             <a:r>
-              <a:rPr lang="en-US" altLang="ko-KR" sz="1400" dirty="0" smtClean="0">
+              <a:rPr lang="en-US" altLang="ko-KR" sz="1400" dirty="0">
                 <a:solidFill>
                   <a:schemeClr val="bg1"/>
                 </a:solidFill>
@@ -5374,10 +5338,9 @@
           <a:lstStyle/>
           <a:p>
             <a:r>
-              <a:rPr lang="ko-KR" altLang="en-US" sz="1500" dirty="0" smtClean="0"/>
+              <a:rPr lang="ko-KR" altLang="en-US" sz="1500" dirty="0"/>
               <a:t>구현</a:t>
             </a:r>
-            <a:endParaRPr lang="ko-KR" altLang="en-US" sz="1500" dirty="0"/>
           </a:p>
         </p:txBody>
       </p:sp>
@@ -5404,10 +5367,9 @@
           <a:lstStyle/>
           <a:p>
             <a:r>
-              <a:rPr lang="ko-KR" altLang="en-US" sz="1500" dirty="0" smtClean="0"/>
+              <a:rPr lang="ko-KR" altLang="en-US" sz="1500" dirty="0"/>
               <a:t>연구과제 프로젝트</a:t>
             </a:r>
-            <a:endParaRPr lang="ko-KR" altLang="en-US" sz="1500" dirty="0"/>
           </a:p>
         </p:txBody>
       </p:sp>
@@ -5451,7 +5413,7 @@
           <a:p>
             <a:pPr algn="ctr"/>
             <a:r>
-              <a:rPr lang="en-US" altLang="ko-KR" sz="1400" dirty="0" err="1" smtClean="0">
+              <a:rPr lang="en-US" altLang="ko-KR" sz="1400" dirty="0" err="1">
                 <a:solidFill>
                   <a:schemeClr val="tx1"/>
                 </a:solidFill>
@@ -5506,7 +5468,7 @@
           <a:p>
             <a:pPr algn="ctr"/>
             <a:r>
-              <a:rPr lang="en-US" altLang="ko-KR" sz="1400" dirty="0" smtClean="0">
+              <a:rPr lang="en-US" altLang="ko-KR" sz="1400" dirty="0">
                 <a:solidFill>
                   <a:schemeClr val="tx1"/>
                 </a:solidFill>
@@ -5561,7 +5523,7 @@
           <a:p>
             <a:pPr algn="ctr"/>
             <a:r>
-              <a:rPr lang="en-US" altLang="ko-KR" sz="1400" dirty="0" smtClean="0">
+              <a:rPr lang="en-US" altLang="ko-KR" sz="1400" dirty="0">
                 <a:solidFill>
                   <a:schemeClr val="tx1"/>
                 </a:solidFill>
@@ -5616,7 +5578,7 @@
           <a:p>
             <a:pPr algn="ctr"/>
             <a:r>
-              <a:rPr lang="en-US" altLang="ko-KR" sz="1400" dirty="0" smtClean="0">
+              <a:rPr lang="en-US" altLang="ko-KR" sz="1400" dirty="0">
                 <a:solidFill>
                   <a:schemeClr val="tx1"/>
                 </a:solidFill>
@@ -5671,7 +5633,7 @@
           <a:p>
             <a:pPr algn="ctr"/>
             <a:r>
-              <a:rPr lang="en-US" altLang="ko-KR" sz="1400" dirty="0" smtClean="0">
+              <a:rPr lang="en-US" altLang="ko-KR" sz="1400" dirty="0">
                 <a:solidFill>
                   <a:schemeClr val="tx1"/>
                 </a:solidFill>
@@ -5726,7 +5688,7 @@
           <a:p>
             <a:pPr algn="ctr"/>
             <a:r>
-              <a:rPr lang="en-US" altLang="ko-KR" sz="1400" dirty="0" err="1" smtClean="0">
+              <a:rPr lang="en-US" altLang="ko-KR" sz="1400" dirty="0" err="1">
                 <a:solidFill>
                   <a:schemeClr val="tx1"/>
                 </a:solidFill>
@@ -5837,46 +5799,38 @@
           <a:p>
             <a:pPr algn="ctr"/>
             <a:r>
-              <a:rPr lang="en-US" altLang="ko-KR" sz="1500" dirty="0" err="1" smtClean="0"/>
+              <a:rPr lang="en-US" altLang="ko-KR" sz="1500" dirty="0" err="1"/>
               <a:t>ImGui</a:t>
+            </a:r>
+            <a:r>
+              <a:rPr lang="ko-KR" altLang="en-US" sz="1500" dirty="0"/>
+              <a:t> 라이브러리 활용</a:t>
+            </a:r>
+            <a:br>
+              <a:rPr lang="en-US" altLang="ko-KR" sz="1500" dirty="0"/>
+            </a:br>
+            <a:r>
+              <a:rPr lang="en-US" altLang="ko-KR" sz="1500" dirty="0"/>
+              <a:t>UI </a:t>
+            </a:r>
+            <a:r>
+              <a:rPr lang="ko-KR" altLang="en-US" sz="1500" dirty="0"/>
+              <a:t>업데이트</a:t>
+            </a:r>
+            <a:r>
+              <a:rPr lang="en-US" altLang="ko-KR" sz="1500" dirty="0"/>
+              <a:t>,</a:t>
             </a:r>
             <a:r>
               <a:rPr lang="ko-KR" altLang="en-US" sz="1500" dirty="0"/>
               <a:t> </a:t>
             </a:r>
             <a:r>
-              <a:rPr lang="ko-KR" altLang="en-US" sz="1500" dirty="0" smtClean="0"/>
-              <a:t>라이브러리 활용</a:t>
-            </a:r>
-            <a:r>
-              <a:rPr lang="en-US" altLang="ko-KR" sz="1500" dirty="0" smtClean="0"/>
-              <a:t/>
-            </a:r>
-            <a:br>
-              <a:rPr lang="en-US" altLang="ko-KR" sz="1500" dirty="0" smtClean="0"/>
-            </a:br>
-            <a:r>
-              <a:rPr lang="en-US" altLang="ko-KR" sz="1500" dirty="0" smtClean="0"/>
-              <a:t>UI </a:t>
-            </a:r>
-            <a:r>
-              <a:rPr lang="ko-KR" altLang="en-US" sz="1500" dirty="0" smtClean="0"/>
-              <a:t>업데이트</a:t>
-            </a:r>
-            <a:r>
-              <a:rPr lang="en-US" altLang="ko-KR" sz="1500" dirty="0" smtClean="0"/>
-              <a:t>,</a:t>
-            </a:r>
-            <a:r>
-              <a:rPr lang="ko-KR" altLang="en-US" sz="1500" dirty="0" smtClean="0"/>
-              <a:t> </a:t>
-            </a:r>
-            <a:r>
-              <a:rPr lang="ko-KR" altLang="en-US" sz="1500" dirty="0" err="1" smtClean="0"/>
+              <a:rPr lang="ko-KR" altLang="en-US" sz="1500" dirty="0" err="1"/>
               <a:t>렌더링</a:t>
             </a:r>
             <a:r>
-              <a:rPr lang="en-US" altLang="ko-KR" sz="1500" dirty="0" smtClean="0"/>
+              <a:rPr lang="en-US" altLang="ko-KR" sz="1500" dirty="0"/>
               <a:t> </a:t>
             </a:r>
             <a:endParaRPr lang="ko-KR" altLang="en-US" sz="1500" dirty="0"/>
@@ -5944,15 +5898,15 @@
           <a:lstStyle/>
           <a:p>
             <a:r>
-              <a:rPr lang="ko-KR" altLang="en-US" sz="1500" dirty="0" smtClean="0"/>
+              <a:rPr lang="ko-KR" altLang="en-US" sz="1500" dirty="0"/>
               <a:t>업데이트</a:t>
             </a:r>
             <a:r>
-              <a:rPr lang="en-US" altLang="ko-KR" sz="1500" dirty="0" smtClean="0"/>
+              <a:rPr lang="en-US" altLang="ko-KR" sz="1500" dirty="0"/>
               <a:t>, </a:t>
             </a:r>
             <a:r>
-              <a:rPr lang="ko-KR" altLang="en-US" sz="1500" dirty="0" err="1" smtClean="0"/>
+              <a:rPr lang="ko-KR" altLang="en-US" sz="1500" dirty="0" err="1"/>
               <a:t>렌더링</a:t>
             </a:r>
             <a:endParaRPr lang="ko-KR" altLang="en-US" sz="1500" dirty="0"/>
@@ -6090,10 +6044,9 @@
           <a:lstStyle/>
           <a:p>
             <a:r>
-              <a:rPr lang="ko-KR" altLang="en-US" sz="1500" dirty="0" smtClean="0"/>
+              <a:rPr lang="ko-KR" altLang="en-US" sz="1500" dirty="0"/>
               <a:t>객체 기반 클래스</a:t>
             </a:r>
-            <a:endParaRPr lang="ko-KR" altLang="en-US" sz="1500" dirty="0"/>
           </a:p>
         </p:txBody>
       </p:sp>
@@ -6120,30 +6073,26 @@
           <a:lstStyle/>
           <a:p>
             <a:r>
-              <a:rPr lang="ko-KR" altLang="en-US" sz="1500" dirty="0" err="1" smtClean="0"/>
+              <a:rPr lang="ko-KR" altLang="en-US" sz="1500" dirty="0" err="1"/>
               <a:t>인스턴스</a:t>
             </a:r>
             <a:r>
-              <a:rPr lang="ko-KR" altLang="en-US" sz="1500" dirty="0" smtClean="0"/>
+              <a:rPr lang="ko-KR" altLang="en-US" sz="1500" dirty="0"/>
               <a:t> 관리</a:t>
             </a:r>
-            <a:r>
-              <a:rPr lang="en-US" altLang="ko-KR" sz="1500" dirty="0" smtClean="0"/>
-              <a:t/>
-            </a:r>
             <a:br>
-              <a:rPr lang="en-US" altLang="ko-KR" sz="1500" dirty="0" smtClean="0"/>
+              <a:rPr lang="en-US" altLang="ko-KR" sz="1500" dirty="0"/>
             </a:br>
             <a:r>
-              <a:rPr lang="ko-KR" altLang="en-US" sz="1500" dirty="0" smtClean="0"/>
+              <a:rPr lang="ko-KR" altLang="en-US" sz="1500" dirty="0"/>
               <a:t>업데이트</a:t>
             </a:r>
             <a:r>
-              <a:rPr lang="en-US" altLang="ko-KR" sz="1500" dirty="0" smtClean="0"/>
+              <a:rPr lang="en-US" altLang="ko-KR" sz="1500" dirty="0"/>
               <a:t>, </a:t>
             </a:r>
             <a:r>
-              <a:rPr lang="ko-KR" altLang="en-US" sz="1500" dirty="0" err="1" smtClean="0"/>
+              <a:rPr lang="ko-KR" altLang="en-US" sz="1500" dirty="0" err="1"/>
               <a:t>렌더링</a:t>
             </a:r>
             <a:endParaRPr lang="ko-KR" altLang="en-US" sz="1500" dirty="0"/>
@@ -6173,22 +6122,18 @@
           <a:lstStyle/>
           <a:p>
             <a:r>
-              <a:rPr lang="ko-KR" altLang="en-US" sz="1500" dirty="0" smtClean="0"/>
+              <a:rPr lang="ko-KR" altLang="en-US" sz="1500" dirty="0"/>
               <a:t>게임 루프에서 </a:t>
             </a:r>
-            <a:r>
-              <a:rPr lang="en-US" altLang="ko-KR" sz="1500" dirty="0" smtClean="0"/>
-              <a:t/>
-            </a:r>
             <a:br>
-              <a:rPr lang="en-US" altLang="ko-KR" sz="1500" dirty="0" smtClean="0"/>
+              <a:rPr lang="en-US" altLang="ko-KR" sz="1500" dirty="0"/>
             </a:br>
             <a:r>
-              <a:rPr lang="ko-KR" altLang="en-US" sz="1500" dirty="0" smtClean="0"/>
+              <a:rPr lang="ko-KR" altLang="en-US" sz="1500" dirty="0"/>
               <a:t>업데이트 및 </a:t>
             </a:r>
             <a:r>
-              <a:rPr lang="ko-KR" altLang="en-US" sz="1500" dirty="0" err="1" smtClean="0"/>
+              <a:rPr lang="ko-KR" altLang="en-US" sz="1500" dirty="0" err="1"/>
               <a:t>렌더링</a:t>
             </a:r>
             <a:endParaRPr lang="ko-KR" altLang="en-US" sz="1500" dirty="0"/>
@@ -6255,10 +6200,9 @@
           <a:p>
             <a:pPr algn="ctr"/>
             <a:r>
-              <a:rPr lang="ko-KR" altLang="en-US" sz="1500" dirty="0" smtClean="0"/>
+              <a:rPr lang="ko-KR" altLang="en-US" sz="1500" dirty="0"/>
               <a:t>상속</a:t>
             </a:r>
-            <a:endParaRPr lang="ko-KR" altLang="en-US" sz="1500" dirty="0"/>
           </a:p>
         </p:txBody>
       </p:sp>
@@ -6286,22 +6230,21 @@
           <a:p>
             <a:pPr algn="r"/>
             <a:r>
-              <a:rPr lang="ko-KR" altLang="en-US" sz="1500" dirty="0" err="1" smtClean="0"/>
+              <a:rPr lang="ko-KR" altLang="en-US" sz="1500" dirty="0" err="1"/>
               <a:t>씬에</a:t>
             </a:r>
             <a:r>
-              <a:rPr lang="ko-KR" altLang="en-US" sz="1500" dirty="0" smtClean="0"/>
+              <a:rPr lang="ko-KR" altLang="en-US" sz="1500" dirty="0"/>
               <a:t> 배치될 수 있는 객체</a:t>
             </a:r>
-            <a:endParaRPr lang="en-US" altLang="ko-KR" sz="1500" dirty="0" smtClean="0"/>
+            <a:endParaRPr lang="en-US" altLang="ko-KR" sz="1500" dirty="0"/>
           </a:p>
           <a:p>
             <a:pPr algn="r"/>
             <a:r>
-              <a:rPr lang="ko-KR" altLang="en-US" sz="1500" dirty="0" smtClean="0"/>
+              <a:rPr lang="ko-KR" altLang="en-US" sz="1500" dirty="0"/>
               <a:t>컴포넌트로 기능 확장</a:t>
             </a:r>
-            <a:endParaRPr lang="ko-KR" altLang="en-US" sz="1500" dirty="0"/>
           </a:p>
         </p:txBody>
       </p:sp>
@@ -6328,25 +6271,20 @@
           <a:lstStyle/>
           <a:p>
             <a:r>
-              <a:rPr lang="ko-KR" altLang="en-US" sz="1500" dirty="0" err="1" smtClean="0"/>
+              <a:rPr lang="ko-KR" altLang="en-US" sz="1500" dirty="0" err="1"/>
               <a:t>액터의</a:t>
             </a:r>
             <a:r>
-              <a:rPr lang="ko-KR" altLang="en-US" sz="1500" dirty="0" smtClean="0"/>
+              <a:rPr lang="ko-KR" altLang="en-US" sz="1500" dirty="0"/>
               <a:t> </a:t>
             </a:r>
-            <a:r>
-              <a:rPr lang="en-US" altLang="ko-KR" sz="1500" dirty="0" smtClean="0"/>
-              <a:t/>
-            </a:r>
             <a:br>
-              <a:rPr lang="en-US" altLang="ko-KR" sz="1500" dirty="0" smtClean="0"/>
+              <a:rPr lang="en-US" altLang="ko-KR" sz="1500" dirty="0"/>
             </a:br>
             <a:r>
-              <a:rPr lang="ko-KR" altLang="en-US" sz="1500" dirty="0" smtClean="0"/>
+              <a:rPr lang="ko-KR" altLang="en-US" sz="1500" dirty="0"/>
               <a:t>기능 확장 클래스</a:t>
             </a:r>
-            <a:endParaRPr lang="ko-KR" altLang="en-US" sz="1500" dirty="0"/>
           </a:p>
         </p:txBody>
       </p:sp>
@@ -6374,10 +6312,9 @@
           <a:p>
             <a:pPr algn="ctr"/>
             <a:r>
-              <a:rPr lang="ko-KR" altLang="en-US" sz="1500" dirty="0" smtClean="0"/>
+              <a:rPr lang="ko-KR" altLang="en-US" sz="1500" dirty="0"/>
               <a:t>의존</a:t>
             </a:r>
-            <a:endParaRPr lang="ko-KR" altLang="en-US" sz="1500" dirty="0"/>
           </a:p>
         </p:txBody>
       </p:sp>
@@ -6402,7 +6339,7 @@
         <p:cNvPr id="1" name="">
           <a:extLst>
             <a:ext uri="{FF2B5EF4-FFF2-40B4-BE49-F238E27FC236}">
-              <a16:creationId xmlns="" xmlns:a16="http://schemas.microsoft.com/office/drawing/2014/main" id="{068E24C7-A429-CDA0-4EB6-16142BB05552}"/>
+              <a16:creationId xmlns:a16="http://schemas.microsoft.com/office/drawing/2014/main" id="{068E24C7-A429-CDA0-4EB6-16142BB05552}"/>
             </a:ext>
           </a:extLst>
         </p:cNvPr>
@@ -6422,7 +6359,7 @@
           <p:cNvPr id="5" name="TextBox 4">
             <a:extLst>
               <a:ext uri="{FF2B5EF4-FFF2-40B4-BE49-F238E27FC236}">
-                <a16:creationId xmlns="" xmlns:a16="http://schemas.microsoft.com/office/drawing/2014/main" id="{4715F932-2F2C-4A3F-7F16-1B13D352985A}"/>
+                <a16:creationId xmlns:a16="http://schemas.microsoft.com/office/drawing/2014/main" id="{4715F932-2F2C-4A3F-7F16-1B13D352985A}"/>
               </a:ext>
             </a:extLst>
           </p:cNvPr>
@@ -6479,26 +6416,22 @@
               <a:buChar char="•"/>
             </a:pPr>
             <a:r>
-              <a:rPr lang="en-US" altLang="ko-KR" sz="1600" dirty="0" err="1" smtClean="0"/>
+              <a:rPr lang="en-US" altLang="ko-KR" sz="1600" dirty="0" err="1"/>
               <a:t>fbx</a:t>
             </a:r>
             <a:r>
-              <a:rPr lang="ko-KR" altLang="en-US" sz="1600" dirty="0" smtClean="0"/>
+              <a:rPr lang="ko-KR" altLang="en-US" sz="1600" dirty="0"/>
+              <a:t> 파일 </a:t>
+            </a:r>
+            <a:r>
+              <a:rPr lang="ko-KR" altLang="en-US" sz="1600" dirty="0" err="1"/>
+              <a:t>파싱</a:t>
+            </a:r>
+            <a:r>
+              <a:rPr lang="ko-KR" altLang="en-US" sz="1600" dirty="0"/>
               <a:t> </a:t>
             </a:r>
-            <a:r>
-              <a:rPr lang="ko-KR" altLang="en-US" sz="1600" dirty="0"/>
-              <a:t>파일 </a:t>
-            </a:r>
-            <a:r>
-              <a:rPr lang="ko-KR" altLang="en-US" sz="1600" dirty="0" err="1" smtClean="0"/>
-              <a:t>파싱</a:t>
-            </a:r>
-            <a:r>
-              <a:rPr lang="ko-KR" altLang="en-US" sz="1600" dirty="0" smtClean="0"/>
-              <a:t> </a:t>
-            </a:r>
-            <a:endParaRPr lang="en-US" altLang="ko-KR" sz="1600" dirty="0" smtClean="0"/>
+            <a:endParaRPr lang="en-US" altLang="ko-KR" sz="1600" dirty="0"/>
           </a:p>
           <a:p>
             <a:pPr marL="742950" lvl="1" indent="-285750">
@@ -6506,11 +6439,11 @@
               <a:buChar char="•"/>
             </a:pPr>
             <a:r>
-              <a:rPr lang="en-US" altLang="ko-KR" sz="1600" dirty="0" err="1" smtClean="0"/>
+              <a:rPr lang="en-US" altLang="ko-KR" sz="1600" dirty="0" err="1"/>
               <a:t>Assimp</a:t>
             </a:r>
             <a:r>
-              <a:rPr lang="en-US" altLang="ko-KR" sz="1600" dirty="0" smtClean="0"/>
+              <a:rPr lang="en-US" altLang="ko-KR" sz="1600" dirty="0"/>
               <a:t> </a:t>
             </a:r>
             <a:r>
@@ -6523,15 +6456,7 @@
             </a:r>
             <a:r>
               <a:rPr lang="ko-KR" altLang="en-US" sz="1600" dirty="0"/>
-              <a:t>에 한정되지 않도록 </a:t>
-            </a:r>
-            <a:r>
-              <a:rPr lang="ko-KR" altLang="en-US" sz="1600" dirty="0" smtClean="0"/>
-              <a:t>수정 </a:t>
-            </a:r>
-            <a:r>
-              <a:rPr lang="ko-KR" altLang="en-US" sz="1600" dirty="0"/>
-              <a:t>진행 중</a:t>
+              <a:t>에 한정되지 않도록 수정 진행 중</a:t>
             </a:r>
             <a:endParaRPr lang="en-US" altLang="ko-KR" sz="1600" dirty="0"/>
           </a:p>
@@ -6541,15 +6466,15 @@
               <a:buChar char="•"/>
             </a:pPr>
             <a:r>
-              <a:rPr lang="en-US" altLang="ko-KR" sz="1600" dirty="0" err="1" smtClean="0"/>
+              <a:rPr lang="en-US" altLang="ko-KR" sz="1600" dirty="0" err="1"/>
               <a:t>fbx</a:t>
             </a:r>
             <a:r>
-              <a:rPr lang="en-US" altLang="ko-KR" sz="1600" dirty="0" smtClean="0"/>
+              <a:rPr lang="en-US" altLang="ko-KR" sz="1600" dirty="0"/>
               <a:t> </a:t>
             </a:r>
             <a:r>
-              <a:rPr lang="ko-KR" altLang="en-US" sz="1600" dirty="0" smtClean="0"/>
+              <a:rPr lang="ko-KR" altLang="en-US" sz="1600" dirty="0"/>
               <a:t>객체 </a:t>
             </a:r>
             <a:r>
@@ -6565,11 +6490,7 @@
             </a:pPr>
             <a:r>
               <a:rPr lang="ko-KR" altLang="en-US" sz="1600" dirty="0"/>
-              <a:t>애니메이션 로드 및 </a:t>
-            </a:r>
-            <a:r>
-              <a:rPr lang="ko-KR" altLang="en-US" sz="1600" dirty="0" smtClean="0"/>
-              <a:t>재생</a:t>
+              <a:t>애니메이션 로드 및 재생</a:t>
             </a:r>
             <a:endParaRPr lang="en-US" altLang="ko-KR" sz="1600" dirty="0"/>
           </a:p>
@@ -6599,7 +6520,7 @@
               <a:t>진행 중</a:t>
             </a:r>
             <a:r>
-              <a:rPr lang="en-US" altLang="ko-KR" sz="1600" dirty="0" smtClean="0"/>
+              <a:rPr lang="en-US" altLang="ko-KR" sz="1600" dirty="0"/>
               <a:t>)</a:t>
             </a:r>
           </a:p>
@@ -6609,23 +6530,23 @@
               <a:buChar char="•"/>
             </a:pPr>
             <a:r>
-              <a:rPr lang="ko-KR" altLang="en-US" sz="1600" dirty="0" smtClean="0"/>
+              <a:rPr lang="ko-KR" altLang="en-US" sz="1600" dirty="0"/>
               <a:t>자체 </a:t>
             </a:r>
             <a:r>
-              <a:rPr lang="ko-KR" altLang="en-US" sz="1600" dirty="0" err="1" smtClean="0"/>
+              <a:rPr lang="ko-KR" altLang="en-US" sz="1600" dirty="0" err="1"/>
               <a:t>메쉬</a:t>
             </a:r>
             <a:r>
-              <a:rPr lang="en-US" altLang="ko-KR" sz="1600" dirty="0" smtClean="0"/>
+              <a:rPr lang="en-US" altLang="ko-KR" sz="1600" dirty="0"/>
               <a:t>, </a:t>
             </a:r>
             <a:r>
-              <a:rPr lang="ko-KR" altLang="en-US" sz="1600" dirty="0" err="1" smtClean="0"/>
+              <a:rPr lang="ko-KR" altLang="en-US" sz="1600" dirty="0" err="1"/>
               <a:t>스켈레톤</a:t>
             </a:r>
             <a:r>
-              <a:rPr lang="ko-KR" altLang="en-US" sz="1600" dirty="0" smtClean="0"/>
+              <a:rPr lang="ko-KR" altLang="en-US" sz="1600" dirty="0"/>
               <a:t> 데이터 기반 작업</a:t>
             </a:r>
             <a:endParaRPr lang="en-US" altLang="ko-KR" sz="1600" dirty="0"/>
@@ -6634,20 +6555,20 @@
       </p:sp>
       <p:sp>
         <p:nvSpPr>
-          <p:cNvPr id="2" name="직사각형 1"/>
+          <p:cNvPr id="11" name="직사각형 10"/>
           <p:cNvSpPr/>
           <p:nvPr/>
         </p:nvSpPr>
         <p:spPr>
           <a:xfrm>
-            <a:off x="422032" y="3818373"/>
-            <a:ext cx="3537019" cy="2301073"/>
+            <a:off x="5737263" y="1473536"/>
+            <a:ext cx="1858944" cy="552661"/>
           </a:xfrm>
           <a:prstGeom prst="rect">
             <a:avLst/>
           </a:prstGeom>
           <a:solidFill>
-            <a:schemeClr val="tx2"/>
+            <a:schemeClr val="bg2"/>
           </a:solidFill>
         </p:spPr>
         <p:style>
@@ -6672,33 +6593,37 @@
           <a:p>
             <a:pPr algn="ctr"/>
             <a:r>
-              <a:rPr lang="ko-KR" altLang="en-US" dirty="0" err="1" smtClean="0"/>
-              <a:t>큐브</a:t>
-            </a:r>
-            <a:r>
-              <a:rPr lang="ko-KR" altLang="en-US" dirty="0" smtClean="0"/>
-              <a:t> 이미지 추가</a:t>
-            </a:r>
-            <a:endParaRPr lang="ko-KR" altLang="en-US" dirty="0"/>
-          </a:p>
-        </p:txBody>
-      </p:sp>
-      <p:sp>
-        <p:nvSpPr>
-          <p:cNvPr id="8" name="직사각형 7"/>
+              <a:rPr lang="en-US" altLang="ko-KR" sz="1400" dirty="0" err="1">
+                <a:solidFill>
+                  <a:schemeClr val="tx1"/>
+                </a:solidFill>
+              </a:rPr>
+              <a:t>ModelData</a:t>
+            </a:r>
+            <a:endParaRPr lang="ko-KR" altLang="en-US" sz="1400" dirty="0">
+              <a:solidFill>
+                <a:schemeClr val="tx1"/>
+              </a:solidFill>
+            </a:endParaRPr>
+          </a:p>
+        </p:txBody>
+      </p:sp>
+      <p:sp>
+        <p:nvSpPr>
+          <p:cNvPr id="12" name="직사각형 11"/>
           <p:cNvSpPr/>
           <p:nvPr/>
         </p:nvSpPr>
         <p:spPr>
           <a:xfrm>
-            <a:off x="4267201" y="3818373"/>
-            <a:ext cx="3537019" cy="2301073"/>
+            <a:off x="5737263" y="2144399"/>
+            <a:ext cx="1858944" cy="552661"/>
           </a:xfrm>
           <a:prstGeom prst="rect">
             <a:avLst/>
           </a:prstGeom>
           <a:solidFill>
-            <a:schemeClr val="tx2"/>
+            <a:schemeClr val="bg2"/>
           </a:solidFill>
         </p:spPr>
         <p:style>
@@ -6723,33 +6648,37 @@
           <a:p>
             <a:pPr algn="ctr"/>
             <a:r>
-              <a:rPr lang="en-US" altLang="ko-KR" dirty="0" smtClean="0"/>
-              <a:t>X bot </a:t>
-            </a:r>
-            <a:r>
-              <a:rPr lang="ko-KR" altLang="en-US" dirty="0" smtClean="0"/>
-              <a:t>이미지 추가</a:t>
-            </a:r>
-            <a:endParaRPr lang="ko-KR" altLang="en-US" dirty="0"/>
-          </a:p>
-        </p:txBody>
-      </p:sp>
-      <p:sp>
-        <p:nvSpPr>
-          <p:cNvPr id="9" name="직사각형 8"/>
+              <a:rPr lang="en-US" altLang="ko-KR" sz="1400" dirty="0">
+                <a:solidFill>
+                  <a:schemeClr val="tx1"/>
+                </a:solidFill>
+              </a:rPr>
+              <a:t>Renderer</a:t>
+            </a:r>
+            <a:endParaRPr lang="ko-KR" altLang="en-US" sz="1400" dirty="0">
+              <a:solidFill>
+                <a:schemeClr val="tx1"/>
+              </a:solidFill>
+            </a:endParaRPr>
+          </a:p>
+        </p:txBody>
+      </p:sp>
+      <p:sp>
+        <p:nvSpPr>
+          <p:cNvPr id="13" name="직사각형 12"/>
           <p:cNvSpPr/>
           <p:nvPr/>
         </p:nvSpPr>
         <p:spPr>
           <a:xfrm>
-            <a:off x="8112371" y="3818373"/>
-            <a:ext cx="3537019" cy="2301073"/>
+            <a:off x="8519329" y="1749866"/>
+            <a:ext cx="1858944" cy="552661"/>
           </a:xfrm>
           <a:prstGeom prst="rect">
             <a:avLst/>
           </a:prstGeom>
           <a:solidFill>
-            <a:schemeClr val="tx2"/>
+            <a:schemeClr val="bg2"/>
           </a:solidFill>
         </p:spPr>
         <p:style>
@@ -6774,22 +6703,30 @@
           <a:p>
             <a:pPr algn="ctr"/>
             <a:r>
-              <a:rPr lang="ko-KR" altLang="en-US" dirty="0" smtClean="0"/>
-              <a:t>애니메이션 이미지 추가</a:t>
-            </a:r>
-            <a:endParaRPr lang="ko-KR" altLang="en-US" dirty="0"/>
-          </a:p>
-        </p:txBody>
-      </p:sp>
-      <p:sp>
-        <p:nvSpPr>
-          <p:cNvPr id="11" name="직사각형 10"/>
+              <a:rPr lang="en-US" altLang="ko-KR" sz="1400" dirty="0" err="1">
+                <a:solidFill>
+                  <a:schemeClr val="tx1"/>
+                </a:solidFill>
+              </a:rPr>
+              <a:t>MeshComponent</a:t>
+            </a:r>
+            <a:endParaRPr lang="ko-KR" altLang="en-US" sz="1400" dirty="0">
+              <a:solidFill>
+                <a:schemeClr val="tx1"/>
+              </a:solidFill>
+            </a:endParaRPr>
+          </a:p>
+        </p:txBody>
+      </p:sp>
+      <p:sp>
+        <p:nvSpPr>
+          <p:cNvPr id="14" name="직사각형 13"/>
           <p:cNvSpPr/>
           <p:nvPr/>
         </p:nvSpPr>
         <p:spPr>
           <a:xfrm>
-            <a:off x="5737263" y="1473536"/>
+            <a:off x="8519329" y="684785"/>
             <a:ext cx="1858944" cy="552661"/>
           </a:xfrm>
           <a:prstGeom prst="rect">
@@ -6821,172 +6758,7 @@
           <a:p>
             <a:pPr algn="ctr"/>
             <a:r>
-              <a:rPr lang="en-US" altLang="ko-KR" sz="1400" dirty="0" err="1" smtClean="0">
-                <a:solidFill>
-                  <a:schemeClr val="tx1"/>
-                </a:solidFill>
-              </a:rPr>
-              <a:t>ModelData</a:t>
-            </a:r>
-            <a:endParaRPr lang="ko-KR" altLang="en-US" sz="1400" dirty="0">
-              <a:solidFill>
-                <a:schemeClr val="tx1"/>
-              </a:solidFill>
-            </a:endParaRPr>
-          </a:p>
-        </p:txBody>
-      </p:sp>
-      <p:sp>
-        <p:nvSpPr>
-          <p:cNvPr id="12" name="직사각형 11"/>
-          <p:cNvSpPr/>
-          <p:nvPr/>
-        </p:nvSpPr>
-        <p:spPr>
-          <a:xfrm>
-            <a:off x="5737263" y="2144399"/>
-            <a:ext cx="1858944" cy="552661"/>
-          </a:xfrm>
-          <a:prstGeom prst="rect">
-            <a:avLst/>
-          </a:prstGeom>
-          <a:solidFill>
-            <a:schemeClr val="bg2"/>
-          </a:solidFill>
-        </p:spPr>
-        <p:style>
-          <a:lnRef idx="2">
-            <a:schemeClr val="accent1">
-              <a:shade val="50000"/>
-            </a:schemeClr>
-          </a:lnRef>
-          <a:fillRef idx="1">
-            <a:schemeClr val="accent1"/>
-          </a:fillRef>
-          <a:effectRef idx="0">
-            <a:schemeClr val="accent1"/>
-          </a:effectRef>
-          <a:fontRef idx="minor">
-            <a:schemeClr val="lt1"/>
-          </a:fontRef>
-        </p:style>
-        <p:txBody>
-          <a:bodyPr rtlCol="0" anchor="ctr"/>
-          <a:lstStyle/>
-          <a:p>
-            <a:pPr algn="ctr"/>
-            <a:r>
-              <a:rPr lang="en-US" altLang="ko-KR" sz="1400" dirty="0" smtClean="0">
-                <a:solidFill>
-                  <a:schemeClr val="tx1"/>
-                </a:solidFill>
-              </a:rPr>
-              <a:t>Renderer</a:t>
-            </a:r>
-            <a:endParaRPr lang="ko-KR" altLang="en-US" sz="1400" dirty="0">
-              <a:solidFill>
-                <a:schemeClr val="tx1"/>
-              </a:solidFill>
-            </a:endParaRPr>
-          </a:p>
-        </p:txBody>
-      </p:sp>
-      <p:sp>
-        <p:nvSpPr>
-          <p:cNvPr id="13" name="직사각형 12"/>
-          <p:cNvSpPr/>
-          <p:nvPr/>
-        </p:nvSpPr>
-        <p:spPr>
-          <a:xfrm>
-            <a:off x="8519329" y="1749866"/>
-            <a:ext cx="1858944" cy="552661"/>
-          </a:xfrm>
-          <a:prstGeom prst="rect">
-            <a:avLst/>
-          </a:prstGeom>
-          <a:solidFill>
-            <a:schemeClr val="bg2"/>
-          </a:solidFill>
-        </p:spPr>
-        <p:style>
-          <a:lnRef idx="2">
-            <a:schemeClr val="accent1">
-              <a:shade val="50000"/>
-            </a:schemeClr>
-          </a:lnRef>
-          <a:fillRef idx="1">
-            <a:schemeClr val="accent1"/>
-          </a:fillRef>
-          <a:effectRef idx="0">
-            <a:schemeClr val="accent1"/>
-          </a:effectRef>
-          <a:fontRef idx="minor">
-            <a:schemeClr val="lt1"/>
-          </a:fontRef>
-        </p:style>
-        <p:txBody>
-          <a:bodyPr rtlCol="0" anchor="ctr"/>
-          <a:lstStyle/>
-          <a:p>
-            <a:pPr algn="ctr"/>
-            <a:r>
-              <a:rPr lang="en-US" altLang="ko-KR" sz="1400" dirty="0" err="1" smtClean="0">
-                <a:solidFill>
-                  <a:schemeClr val="tx1"/>
-                </a:solidFill>
-              </a:rPr>
-              <a:t>MeshComponent</a:t>
-            </a:r>
-            <a:endParaRPr lang="ko-KR" altLang="en-US" sz="1400" dirty="0">
-              <a:solidFill>
-                <a:schemeClr val="tx1"/>
-              </a:solidFill>
-            </a:endParaRPr>
-          </a:p>
-        </p:txBody>
-      </p:sp>
-      <p:sp>
-        <p:nvSpPr>
-          <p:cNvPr id="14" name="직사각형 13"/>
-          <p:cNvSpPr/>
-          <p:nvPr/>
-        </p:nvSpPr>
-        <p:spPr>
-          <a:xfrm>
-            <a:off x="8519329" y="684785"/>
-            <a:ext cx="1858944" cy="552661"/>
-          </a:xfrm>
-          <a:prstGeom prst="rect">
-            <a:avLst/>
-          </a:prstGeom>
-          <a:solidFill>
-            <a:schemeClr val="bg2"/>
-          </a:solidFill>
-        </p:spPr>
-        <p:style>
-          <a:lnRef idx="2">
-            <a:schemeClr val="accent1">
-              <a:shade val="50000"/>
-            </a:schemeClr>
-          </a:lnRef>
-          <a:fillRef idx="1">
-            <a:schemeClr val="accent1"/>
-          </a:fillRef>
-          <a:effectRef idx="0">
-            <a:schemeClr val="accent1"/>
-          </a:effectRef>
-          <a:fontRef idx="minor">
-            <a:schemeClr val="lt1"/>
-          </a:fontRef>
-        </p:style>
-        <p:txBody>
-          <a:bodyPr rtlCol="0" anchor="ctr"/>
-          <a:lstStyle/>
-          <a:p>
-            <a:pPr algn="ctr"/>
-            <a:r>
-              <a:rPr lang="en-US" altLang="ko-KR" sz="1400" dirty="0" smtClean="0">
+              <a:rPr lang="en-US" altLang="ko-KR" sz="1400" dirty="0">
                 <a:solidFill>
                   <a:schemeClr val="tx1"/>
                 </a:solidFill>
@@ -7149,30 +6921,22 @@
           <a:p>
             <a:pPr algn="ctr"/>
             <a:r>
-              <a:rPr lang="en-US" altLang="ko-KR" sz="1400" dirty="0" err="1" smtClean="0">
+              <a:rPr lang="en-US" altLang="ko-KR" sz="1400" dirty="0" err="1">
                 <a:solidFill>
                   <a:schemeClr val="tx1"/>
                 </a:solidFill>
               </a:rPr>
               <a:t>SkinnedMesh</a:t>
             </a:r>
-            <a:r>
-              <a:rPr lang="en-US" altLang="ko-KR" sz="1400" dirty="0" smtClean="0">
-                <a:solidFill>
-                  <a:schemeClr val="tx1"/>
-                </a:solidFill>
-              </a:rPr>
-              <a:t/>
-            </a:r>
             <a:br>
-              <a:rPr lang="en-US" altLang="ko-KR" sz="1400" dirty="0" smtClean="0">
+              <a:rPr lang="en-US" altLang="ko-KR" sz="1400" dirty="0">
                 <a:solidFill>
                   <a:schemeClr val="tx1"/>
                 </a:solidFill>
               </a:rPr>
             </a:br>
             <a:r>
-              <a:rPr lang="en-US" altLang="ko-KR" sz="1400" dirty="0" smtClean="0">
+              <a:rPr lang="en-US" altLang="ko-KR" sz="1400" dirty="0">
                 <a:solidFill>
                   <a:schemeClr val="tx1"/>
                 </a:solidFill>
@@ -7227,7 +6991,7 @@
           <a:p>
             <a:pPr algn="ctr"/>
             <a:r>
-              <a:rPr lang="en-US" altLang="ko-KR" sz="1400" dirty="0" smtClean="0">
+              <a:rPr lang="en-US" altLang="ko-KR" sz="1400" dirty="0">
                 <a:solidFill>
                   <a:schemeClr val="tx1"/>
                 </a:solidFill>
@@ -7338,10 +7102,9 @@
           <a:p>
             <a:pPr algn="ctr"/>
             <a:r>
-              <a:rPr lang="ko-KR" altLang="en-US" sz="1500" dirty="0" smtClean="0"/>
+              <a:rPr lang="ko-KR" altLang="en-US" sz="1500" dirty="0"/>
               <a:t>상속</a:t>
             </a:r>
-            <a:endParaRPr lang="ko-KR" altLang="en-US" sz="1500" dirty="0"/>
           </a:p>
         </p:txBody>
       </p:sp>
@@ -7369,10 +7132,9 @@
           <a:p>
             <a:pPr algn="ctr"/>
             <a:r>
-              <a:rPr lang="ko-KR" altLang="en-US" sz="1500" dirty="0" smtClean="0"/>
+              <a:rPr lang="ko-KR" altLang="en-US" sz="1500" dirty="0"/>
               <a:t>상속</a:t>
             </a:r>
-            <a:endParaRPr lang="ko-KR" altLang="en-US" sz="1500" dirty="0"/>
           </a:p>
         </p:txBody>
       </p:sp>
@@ -7400,21 +7162,94 @@
           <a:p>
             <a:pPr algn="ctr"/>
             <a:r>
-              <a:rPr lang="en-US" altLang="ko-KR" sz="1500" dirty="0" err="1" smtClean="0"/>
+              <a:rPr lang="en-US" altLang="ko-KR" sz="1500" dirty="0" err="1"/>
               <a:t>MeshComponent</a:t>
             </a:r>
             <a:r>
-              <a:rPr lang="en-US" altLang="ko-KR" sz="1500" dirty="0" smtClean="0"/>
+              <a:rPr lang="en-US" altLang="ko-KR" sz="1500" dirty="0"/>
               <a:t> </a:t>
             </a:r>
             <a:r>
-              <a:rPr lang="ko-KR" altLang="en-US" sz="1500" dirty="0" smtClean="0"/>
+              <a:rPr lang="ko-KR" altLang="en-US" sz="1500" dirty="0"/>
               <a:t>구현 예정</a:t>
             </a:r>
-            <a:endParaRPr lang="ko-KR" altLang="en-US" sz="1500" dirty="0"/>
-          </a:p>
-        </p:txBody>
-      </p:sp>
+          </a:p>
+        </p:txBody>
+      </p:sp>
+      <p:pic>
+        <p:nvPicPr>
+          <p:cNvPr id="4" name="그림 3">
+            <a:extLst>
+              <a:ext uri="{FF2B5EF4-FFF2-40B4-BE49-F238E27FC236}">
+                <a16:creationId xmlns:a16="http://schemas.microsoft.com/office/drawing/2014/main" id="{EED86C46-4E1D-2DF0-2914-2C305EB7A937}"/>
+              </a:ext>
+            </a:extLst>
+          </p:cNvPr>
+          <p:cNvPicPr>
+            <a:picLocks noChangeAspect="1"/>
+          </p:cNvPicPr>
+          <p:nvPr/>
+        </p:nvPicPr>
+        <p:blipFill>
+          <a:blip r:embed="rId2">
+            <a:extLst>
+              <a:ext uri="{28A0092B-C50C-407E-A947-70E740481C1C}">
+                <a14:useLocalDpi xmlns:a14="http://schemas.microsoft.com/office/drawing/2010/main" val="0"/>
+              </a:ext>
+            </a:extLst>
+          </a:blip>
+          <a:srcRect l="26415" t="13270" r="26415" b="10205"/>
+          <a:stretch>
+            <a:fillRect/>
+          </a:stretch>
+        </p:blipFill>
+        <p:spPr>
+          <a:xfrm>
+            <a:off x="426581" y="3655270"/>
+            <a:ext cx="3289236" cy="2916969"/>
+          </a:xfrm>
+          <a:prstGeom prst="rect">
+            <a:avLst/>
+          </a:prstGeom>
+        </p:spPr>
+      </p:pic>
+      <p:pic>
+        <p:nvPicPr>
+          <p:cNvPr id="17" name="그림 16">
+            <a:extLst>
+              <a:ext uri="{FF2B5EF4-FFF2-40B4-BE49-F238E27FC236}">
+                <a16:creationId xmlns:a16="http://schemas.microsoft.com/office/drawing/2014/main" id="{AE49B48B-9ECB-E0E3-3EEE-6C717CC4E952}"/>
+              </a:ext>
+            </a:extLst>
+          </p:cNvPr>
+          <p:cNvPicPr>
+            <a:picLocks noChangeAspect="1"/>
+          </p:cNvPicPr>
+          <p:nvPr/>
+        </p:nvPicPr>
+        <p:blipFill>
+          <a:blip r:embed="rId3">
+            <a:extLst>
+              <a:ext uri="{28A0092B-C50C-407E-A947-70E740481C1C}">
+                <a14:useLocalDpi xmlns:a14="http://schemas.microsoft.com/office/drawing/2010/main" val="0"/>
+              </a:ext>
+            </a:extLst>
+          </a:blip>
+          <a:srcRect l="19628" t="3837" r="33065" b="2583"/>
+          <a:stretch>
+            <a:fillRect/>
+          </a:stretch>
+        </p:blipFill>
+        <p:spPr>
+          <a:xfrm>
+            <a:off x="3944510" y="3649929"/>
+            <a:ext cx="2422518" cy="2922310"/>
+          </a:xfrm>
+          <a:prstGeom prst="rect">
+            <a:avLst/>
+          </a:prstGeom>
+        </p:spPr>
+      </p:pic>
     </p:spTree>
     <p:extLst>
       <p:ext uri="{BB962C8B-B14F-4D97-AF65-F5344CB8AC3E}">
@@ -7436,7 +7271,7 @@
         <p:cNvPr id="1" name="">
           <a:extLst>
             <a:ext uri="{FF2B5EF4-FFF2-40B4-BE49-F238E27FC236}">
-              <a16:creationId xmlns="" xmlns:a16="http://schemas.microsoft.com/office/drawing/2014/main" id="{49DA7EAA-204E-2F90-E52A-6C83B9013025}"/>
+              <a16:creationId xmlns:a16="http://schemas.microsoft.com/office/drawing/2014/main" id="{49DA7EAA-204E-2F90-E52A-6C83B9013025}"/>
             </a:ext>
           </a:extLst>
         </p:cNvPr>
@@ -7456,7 +7291,7 @@
           <p:cNvPr id="5" name="TextBox 4">
             <a:extLst>
               <a:ext uri="{FF2B5EF4-FFF2-40B4-BE49-F238E27FC236}">
-                <a16:creationId xmlns="" xmlns:a16="http://schemas.microsoft.com/office/drawing/2014/main" id="{4715F932-2F2C-4A3F-7F16-1B13D352985A}"/>
+                <a16:creationId xmlns:a16="http://schemas.microsoft.com/office/drawing/2014/main" id="{4715F932-2F2C-4A3F-7F16-1B13D352985A}"/>
               </a:ext>
             </a:extLst>
           </p:cNvPr>
@@ -7527,9 +7362,27 @@
                 <a:tableStyleId>{5C22544A-7EE6-4342-B048-85BDC9FD1C3A}</a:tableStyleId>
               </a:tblPr>
               <a:tblGrid>
-                <a:gridCol w="799719"/>
-                <a:gridCol w="4251311"/>
-                <a:gridCol w="6386284"/>
+                <a:gridCol w="799719">
+                  <a:extLst>
+                    <a:ext uri="{9D8B030D-6E8A-4147-A177-3AD203B41FA5}">
+                      <a16:colId xmlns:a16="http://schemas.microsoft.com/office/drawing/2014/main" val="20000"/>
+                    </a:ext>
+                  </a:extLst>
+                </a:gridCol>
+                <a:gridCol w="4251311">
+                  <a:extLst>
+                    <a:ext uri="{9D8B030D-6E8A-4147-A177-3AD203B41FA5}">
+                      <a16:colId xmlns:a16="http://schemas.microsoft.com/office/drawing/2014/main" val="20001"/>
+                    </a:ext>
+                  </a:extLst>
+                </a:gridCol>
+                <a:gridCol w="6386284">
+                  <a:extLst>
+                    <a:ext uri="{9D8B030D-6E8A-4147-A177-3AD203B41FA5}">
+                      <a16:colId xmlns:a16="http://schemas.microsoft.com/office/drawing/2014/main" val="20002"/>
+                    </a:ext>
+                  </a:extLst>
+                </a:gridCol>
               </a:tblGrid>
               <a:tr h="547281">
                 <a:tc>
@@ -7550,10 +7403,9 @@
                     <a:p>
                       <a:pPr algn="ctr" latinLnBrk="1"/>
                       <a:r>
-                        <a:rPr lang="ko-KR" altLang="en-US" sz="2000" b="0" dirty="0" smtClean="0"/>
+                        <a:rPr lang="ko-KR" altLang="en-US" sz="2000" b="0" dirty="0"/>
                         <a:t>작업 목표</a:t>
                       </a:r>
-                      <a:endParaRPr lang="ko-KR" altLang="en-US" sz="2000" b="0" dirty="0"/>
                     </a:p>
                   </a:txBody>
                   <a:tcPr/>
@@ -7565,14 +7417,18 @@
                     <a:p>
                       <a:pPr algn="ctr" latinLnBrk="1"/>
                       <a:r>
-                        <a:rPr lang="ko-KR" altLang="en-US" sz="2000" b="0" dirty="0" smtClean="0"/>
+                        <a:rPr lang="ko-KR" altLang="en-US" sz="2000" b="0" dirty="0"/>
                         <a:t>작업 세부 내용</a:t>
                       </a:r>
-                      <a:endParaRPr lang="ko-KR" altLang="en-US" sz="2000" b="0" dirty="0"/>
                     </a:p>
                   </a:txBody>
                   <a:tcPr/>
                 </a:tc>
+                <a:extLst>
+                  <a:ext uri="{0D108BD9-81ED-4DB2-BD59-A6C34878D82A}">
+                    <a16:rowId xmlns:a16="http://schemas.microsoft.com/office/drawing/2014/main" val="10000"/>
+                  </a:ext>
+                </a:extLst>
               </a:tr>
               <a:tr h="627956">
                 <a:tc>
@@ -7582,7 +7438,7 @@
                     <a:p>
                       <a:pPr algn="ctr" latinLnBrk="1"/>
                       <a:r>
-                        <a:rPr lang="en-US" altLang="ko-KR" dirty="0" smtClean="0"/>
+                        <a:rPr lang="en-US" altLang="ko-KR" dirty="0"/>
                         <a:t>1</a:t>
                       </a:r>
                       <a:endParaRPr lang="ko-KR" altLang="en-US" dirty="0"/>
@@ -7613,18 +7469,14 @@
                         <a:defRPr/>
                       </a:pPr>
                       <a:r>
-                        <a:rPr lang="ko-KR" altLang="en-US" sz="1600" dirty="0" smtClean="0"/>
-                        <a:t>미니엔진 </a:t>
-                      </a:r>
-                      <a:r>
-                        <a:rPr lang="ko-KR" altLang="en-US" sz="1600" dirty="0" smtClean="0"/>
-                        <a:t>구조 파악 및 기반 클래스</a:t>
-                      </a:r>
-                      <a:r>
-                        <a:rPr lang="ko-KR" altLang="en-US" sz="1600" baseline="0" dirty="0" smtClean="0"/>
+                        <a:rPr lang="ko-KR" altLang="en-US" sz="1600" dirty="0"/>
+                        <a:t>미니엔진 구조 파악 및 기반 클래스</a:t>
+                      </a:r>
+                      <a:r>
+                        <a:rPr lang="ko-KR" altLang="en-US" sz="1600" baseline="0" dirty="0"/>
                         <a:t> 구성</a:t>
                       </a:r>
-                      <a:endParaRPr lang="en-US" altLang="ko-KR" sz="1600" dirty="0" smtClean="0"/>
+                      <a:endParaRPr lang="en-US" altLang="ko-KR" sz="1600" dirty="0"/>
                     </a:p>
                   </a:txBody>
                   <a:tcPr/>
@@ -7639,58 +7491,58 @@
                         <a:buNone/>
                       </a:pPr>
                       <a:r>
-                        <a:rPr lang="ko-KR" altLang="en-US" sz="1600" dirty="0" smtClean="0"/>
+                        <a:rPr lang="ko-KR" altLang="en-US" sz="1600" dirty="0"/>
                         <a:t>미니엔진 파악</a:t>
                       </a:r>
                       <a:r>
-                        <a:rPr lang="en-US" altLang="ko-KR" sz="1600" dirty="0" smtClean="0"/>
+                        <a:rPr lang="en-US" altLang="ko-KR" sz="1600" dirty="0"/>
                         <a:t>, </a:t>
                       </a:r>
                       <a:r>
-                        <a:rPr lang="ko-KR" altLang="en-US" sz="1600" dirty="0" smtClean="0"/>
+                        <a:rPr lang="ko-KR" altLang="en-US" sz="1600" dirty="0"/>
                         <a:t>게임 기반 클래스 작성</a:t>
                       </a:r>
                       <a:r>
-                        <a:rPr lang="en-US" altLang="ko-KR" sz="1600" dirty="0" smtClean="0"/>
+                        <a:rPr lang="en-US" altLang="ko-KR" sz="1600" dirty="0"/>
                         <a:t>, </a:t>
                       </a:r>
                       <a:br>
-                        <a:rPr lang="en-US" altLang="ko-KR" sz="1600" dirty="0" smtClean="0"/>
+                        <a:rPr lang="en-US" altLang="ko-KR" sz="1600" dirty="0"/>
                       </a:br>
                       <a:r>
-                        <a:rPr lang="en-US" altLang="ko-KR" sz="1600" dirty="0" err="1" smtClean="0"/>
+                        <a:rPr lang="en-US" altLang="ko-KR" sz="1600" dirty="0" err="1"/>
                         <a:t>fbx</a:t>
                       </a:r>
                       <a:r>
-                        <a:rPr lang="en-US" altLang="ko-KR" sz="1600" dirty="0" smtClean="0"/>
+                        <a:rPr lang="en-US" altLang="ko-KR" sz="1600" dirty="0"/>
                         <a:t> </a:t>
                       </a:r>
                       <a:r>
-                        <a:rPr lang="ko-KR" altLang="en-US" sz="1600" dirty="0" smtClean="0"/>
+                        <a:rPr lang="ko-KR" altLang="en-US" sz="1600" dirty="0"/>
                         <a:t>파일 </a:t>
                       </a:r>
                       <a:r>
-                        <a:rPr lang="ko-KR" altLang="en-US" sz="1600" dirty="0" err="1" smtClean="0"/>
+                        <a:rPr lang="ko-KR" altLang="en-US" sz="1600" dirty="0" err="1"/>
                         <a:t>파싱</a:t>
                       </a:r>
                       <a:r>
-                        <a:rPr lang="en-US" altLang="ko-KR" sz="1600" baseline="0" dirty="0" smtClean="0"/>
+                        <a:rPr lang="en-US" altLang="ko-KR" sz="1600" baseline="0" dirty="0"/>
                         <a:t>, </a:t>
                       </a:r>
                       <a:r>
-                        <a:rPr lang="ko-KR" altLang="en-US" sz="1600" baseline="0" dirty="0" smtClean="0"/>
+                        <a:rPr lang="ko-KR" altLang="en-US" sz="1600" baseline="0" dirty="0"/>
                         <a:t>씬 </a:t>
                       </a:r>
                       <a:r>
-                        <a:rPr lang="ko-KR" altLang="en-US" sz="1600" baseline="0" dirty="0" err="1" smtClean="0"/>
+                        <a:rPr lang="ko-KR" altLang="en-US" sz="1600" baseline="0" dirty="0" err="1"/>
                         <a:t>렌더링</a:t>
                       </a:r>
                       <a:r>
-                        <a:rPr lang="en-US" altLang="ko-KR" sz="1600" baseline="0" dirty="0" smtClean="0"/>
+                        <a:rPr lang="en-US" altLang="ko-KR" sz="1600" baseline="0" dirty="0"/>
                         <a:t>, </a:t>
                       </a:r>
                       <a:r>
-                        <a:rPr lang="ko-KR" altLang="en-US" sz="1600" baseline="0" dirty="0" smtClean="0"/>
+                        <a:rPr lang="ko-KR" altLang="en-US" sz="1600" baseline="0" dirty="0"/>
                         <a:t>애니메이션 재생</a:t>
                       </a:r>
                       <a:endParaRPr lang="ko-KR" altLang="en-US" sz="1600" dirty="0"/>
@@ -7698,6 +7550,11 @@
                   </a:txBody>
                   <a:tcPr/>
                 </a:tc>
+                <a:extLst>
+                  <a:ext uri="{0D108BD9-81ED-4DB2-BD59-A6C34878D82A}">
+                    <a16:rowId xmlns:a16="http://schemas.microsoft.com/office/drawing/2014/main" val="10001"/>
+                  </a:ext>
+                </a:extLst>
               </a:tr>
               <a:tr h="627956">
                 <a:tc>
@@ -7707,7 +7564,7 @@
                     <a:p>
                       <a:pPr algn="ctr" latinLnBrk="1"/>
                       <a:r>
-                        <a:rPr lang="en-US" altLang="ko-KR" dirty="0" smtClean="0"/>
+                        <a:rPr lang="en-US" altLang="ko-KR" dirty="0"/>
                         <a:t>2</a:t>
                       </a:r>
                       <a:endParaRPr lang="ko-KR" altLang="en-US" dirty="0"/>
@@ -7722,27 +7579,266 @@
                     <a:p>
                       <a:pPr latinLnBrk="1"/>
                       <a:r>
-                        <a:rPr lang="ko-KR" altLang="en-US" sz="1600" dirty="0" smtClean="0"/>
+                        <a:rPr lang="ko-KR" altLang="en-US" sz="1600" dirty="0"/>
                         <a:t>애니메이션 시스템</a:t>
                       </a:r>
                       <a:r>
-                        <a:rPr lang="en-US" altLang="ko-KR" sz="1600" dirty="0" smtClean="0"/>
+                        <a:rPr lang="en-US" altLang="ko-KR" sz="1600" dirty="0"/>
                         <a:t>, </a:t>
                       </a:r>
                       <a:r>
-                        <a:rPr lang="ko-KR" altLang="en-US" sz="1600" dirty="0" smtClean="0"/>
+                        <a:rPr lang="ko-KR" altLang="en-US" sz="1600" dirty="0"/>
                         <a:t>물리엔진 적용</a:t>
                       </a:r>
                       <a:r>
-                        <a:rPr lang="en-US" altLang="ko-KR" sz="1600" dirty="0" smtClean="0"/>
+                        <a:rPr lang="en-US" altLang="ko-KR" sz="1600" dirty="0"/>
                         <a:t>,</a:t>
                       </a:r>
                     </a:p>
                     <a:p>
                       <a:pPr latinLnBrk="1"/>
                       <a:r>
-                        <a:rPr lang="ko-KR" altLang="en-US" sz="1600" dirty="0" smtClean="0"/>
+                        <a:rPr lang="ko-KR" altLang="en-US" sz="1600" dirty="0"/>
                         <a:t>입력 바인딩</a:t>
+                      </a:r>
+                    </a:p>
+                  </a:txBody>
+                  <a:tcPr/>
+                </a:tc>
+                <a:tc>
+                  <a:txBody>
+                    <a:bodyPr/>
+                    <a:lstStyle/>
+                    <a:p>
+                      <a:pPr latinLnBrk="1"/>
+                      <a:r>
+                        <a:rPr lang="ko-KR" altLang="en-US" sz="1600" dirty="0"/>
+                        <a:t>캐릭터 애니메이션 </a:t>
+                      </a:r>
+                      <a:r>
+                        <a:rPr lang="ko-KR" altLang="en-US" sz="1600" dirty="0" err="1"/>
+                        <a:t>블렌드</a:t>
+                      </a:r>
+                      <a:r>
+                        <a:rPr lang="en-US" altLang="ko-KR" sz="1600" dirty="0"/>
+                        <a:t>, </a:t>
+                      </a:r>
+                      <a:r>
+                        <a:rPr lang="ko-KR" altLang="en-US" sz="1600" dirty="0"/>
+                        <a:t>애니메이션 </a:t>
+                      </a:r>
+                      <a:r>
+                        <a:rPr lang="ko-KR" altLang="en-US" sz="1600" dirty="0" err="1"/>
+                        <a:t>상태머신</a:t>
+                      </a:r>
+                      <a:r>
+                        <a:rPr lang="en-US" altLang="ko-KR" sz="1600" dirty="0"/>
+                        <a:t>,</a:t>
+                      </a:r>
+                    </a:p>
+                    <a:p>
+                      <a:pPr latinLnBrk="1"/>
+                      <a:r>
+                        <a:rPr lang="ko-KR" altLang="en-US" sz="1600" dirty="0"/>
+                        <a:t>물리엔진</a:t>
+                      </a:r>
+                      <a:r>
+                        <a:rPr lang="en-US" altLang="ko-KR" sz="1600" dirty="0"/>
+                        <a:t>(PhysX) </a:t>
+                      </a:r>
+                      <a:r>
+                        <a:rPr lang="ko-KR" altLang="en-US" sz="1600" dirty="0"/>
+                        <a:t>적용</a:t>
+                      </a:r>
+                      <a:r>
+                        <a:rPr lang="en-US" altLang="ko-KR" sz="1600" dirty="0"/>
+                        <a:t>, </a:t>
+                      </a:r>
+                      <a:r>
+                        <a:rPr lang="ko-KR" altLang="en-US" sz="1600" dirty="0"/>
+                        <a:t>캐릭터 입력 바인딩</a:t>
+                      </a:r>
+                      <a:r>
+                        <a:rPr lang="en-US" altLang="ko-KR" sz="1600" dirty="0"/>
+                        <a:t>, </a:t>
+                      </a:r>
+                      <a:r>
+                        <a:rPr lang="ko-KR" altLang="en-US" sz="1600" dirty="0"/>
+                        <a:t>캐릭터 </a:t>
+                      </a:r>
+                      <a:r>
+                        <a:rPr lang="ko-KR" altLang="en-US" sz="1600" dirty="0" err="1"/>
+                        <a:t>로코모션</a:t>
+                      </a:r>
+                      <a:r>
+                        <a:rPr lang="ko-KR" altLang="en-US" sz="1600" dirty="0"/>
+                        <a:t> 적용</a:t>
+                      </a:r>
+                    </a:p>
+                  </a:txBody>
+                  <a:tcPr/>
+                </a:tc>
+                <a:extLst>
+                  <a:ext uri="{0D108BD9-81ED-4DB2-BD59-A6C34878D82A}">
+                    <a16:rowId xmlns:a16="http://schemas.microsoft.com/office/drawing/2014/main" val="10002"/>
+                  </a:ext>
+                </a:extLst>
+              </a:tr>
+              <a:tr h="627956">
+                <a:tc>
+                  <a:txBody>
+                    <a:bodyPr/>
+                    <a:lstStyle/>
+                    <a:p>
+                      <a:pPr algn="ctr" latinLnBrk="1"/>
+                      <a:r>
+                        <a:rPr lang="en-US" altLang="ko-KR" dirty="0"/>
+                        <a:t>3</a:t>
+                      </a:r>
+                      <a:endParaRPr lang="ko-KR" altLang="en-US" dirty="0"/>
+                    </a:p>
+                  </a:txBody>
+                  <a:tcPr/>
+                </a:tc>
+                <a:tc>
+                  <a:txBody>
+                    <a:bodyPr/>
+                    <a:lstStyle/>
+                    <a:p>
+                      <a:pPr latinLnBrk="1"/>
+                      <a:r>
+                        <a:rPr lang="ko-KR" altLang="en-US" sz="1600" dirty="0"/>
+                        <a:t>씬 배치</a:t>
+                      </a:r>
+                      <a:r>
+                        <a:rPr lang="en-US" altLang="ko-KR" sz="1600" dirty="0"/>
+                        <a:t>, </a:t>
+                      </a:r>
+                      <a:r>
+                        <a:rPr lang="ko-KR" altLang="en-US" sz="1600" dirty="0"/>
+                        <a:t>캐릭터</a:t>
+                      </a:r>
+                      <a:r>
+                        <a:rPr lang="en-US" altLang="ko-KR" sz="1600" dirty="0"/>
+                        <a:t> </a:t>
+                      </a:r>
+                      <a:r>
+                        <a:rPr lang="ko-KR" altLang="en-US" sz="1600" dirty="0" err="1"/>
+                        <a:t>파쿠르</a:t>
+                      </a:r>
+                      <a:r>
+                        <a:rPr lang="ko-KR" altLang="en-US" sz="1600" dirty="0"/>
+                        <a:t> 애니메이션 적용</a:t>
+                      </a:r>
+                    </a:p>
+                  </a:txBody>
+                  <a:tcPr/>
+                </a:tc>
+                <a:tc>
+                  <a:txBody>
+                    <a:bodyPr/>
+                    <a:lstStyle/>
+                    <a:p>
+                      <a:pPr latinLnBrk="1"/>
+                      <a:r>
+                        <a:rPr lang="ko-KR" altLang="en-US" sz="1600" dirty="0"/>
+                        <a:t>씬</a:t>
+                      </a:r>
+                      <a:r>
+                        <a:rPr lang="en-US" altLang="ko-KR" sz="1600" baseline="0" dirty="0"/>
+                        <a:t> </a:t>
+                      </a:r>
+                      <a:r>
+                        <a:rPr lang="ko-KR" altLang="en-US" sz="1600" baseline="0" dirty="0"/>
+                        <a:t>데이터 직렬화 </a:t>
+                      </a:r>
+                      <a:r>
+                        <a:rPr lang="en-US" altLang="ko-KR" sz="1600" baseline="0" dirty="0"/>
+                        <a:t>(</a:t>
+                      </a:r>
+                      <a:r>
+                        <a:rPr lang="ko-KR" altLang="en-US" sz="1600" baseline="0" dirty="0"/>
+                        <a:t>장애물 배치 정보</a:t>
+                      </a:r>
+                      <a:r>
+                        <a:rPr lang="en-US" altLang="ko-KR" sz="1600" baseline="0" dirty="0"/>
+                        <a:t>), </a:t>
+                      </a:r>
+                      <a:r>
+                        <a:rPr lang="ko-KR" altLang="en-US" sz="1600" baseline="0" dirty="0"/>
+                        <a:t>장애물 높이 인식</a:t>
+                      </a:r>
+                      <a:r>
+                        <a:rPr lang="en-US" altLang="ko-KR" sz="1600" baseline="0" dirty="0"/>
+                        <a:t>, </a:t>
+                      </a:r>
+                      <a:br>
+                        <a:rPr lang="en-US" altLang="ko-KR" sz="1600" baseline="0" dirty="0"/>
+                      </a:br>
+                      <a:r>
+                        <a:rPr lang="ko-KR" altLang="en-US" sz="1600" baseline="0" dirty="0"/>
+                        <a:t>인식한 장애물에 대한 </a:t>
+                      </a:r>
+                      <a:r>
+                        <a:rPr lang="ko-KR" altLang="en-US" sz="1600" baseline="0" dirty="0" err="1"/>
+                        <a:t>파쿠르</a:t>
+                      </a:r>
+                      <a:r>
+                        <a:rPr lang="ko-KR" altLang="en-US" sz="1600" baseline="0" dirty="0"/>
+                        <a:t> 애니메이션 선택</a:t>
+                      </a:r>
+                      <a:r>
+                        <a:rPr lang="en-US" altLang="ko-KR" sz="1600" baseline="0" dirty="0"/>
+                        <a:t> </a:t>
+                      </a:r>
+                      <a:r>
+                        <a:rPr lang="ko-KR" altLang="en-US" sz="1600" baseline="0" dirty="0"/>
+                        <a:t>및 출력</a:t>
+                      </a:r>
+                      <a:endParaRPr lang="ko-KR" altLang="en-US" sz="1600" dirty="0"/>
+                    </a:p>
+                  </a:txBody>
+                  <a:tcPr/>
+                </a:tc>
+                <a:extLst>
+                  <a:ext uri="{0D108BD9-81ED-4DB2-BD59-A6C34878D82A}">
+                    <a16:rowId xmlns:a16="http://schemas.microsoft.com/office/drawing/2014/main" val="10003"/>
+                  </a:ext>
+                </a:extLst>
+              </a:tr>
+              <a:tr h="627956">
+                <a:tc>
+                  <a:txBody>
+                    <a:bodyPr/>
+                    <a:lstStyle/>
+                    <a:p>
+                      <a:pPr algn="ctr" latinLnBrk="1"/>
+                      <a:r>
+                        <a:rPr lang="en-US" altLang="ko-KR" dirty="0"/>
+                        <a:t>4</a:t>
+                      </a:r>
+                      <a:endParaRPr lang="ko-KR" altLang="en-US" dirty="0"/>
+                    </a:p>
+                  </a:txBody>
+                  <a:tcPr/>
+                </a:tc>
+                <a:tc>
+                  <a:txBody>
+                    <a:bodyPr/>
+                    <a:lstStyle/>
+                    <a:p>
+                      <a:pPr latinLnBrk="1"/>
+                      <a:r>
+                        <a:rPr lang="ko-KR" altLang="en-US" sz="1600" dirty="0" err="1"/>
+                        <a:t>파쿠르</a:t>
+                      </a:r>
+                      <a:r>
+                        <a:rPr lang="ko-KR" altLang="en-US" sz="1600" dirty="0"/>
+                        <a:t> </a:t>
+                      </a:r>
+                      <a:r>
+                        <a:rPr lang="ko-KR" altLang="en-US" sz="1600" dirty="0" err="1"/>
+                        <a:t>프로토타입</a:t>
                       </a:r>
                       <a:endParaRPr lang="ko-KR" altLang="en-US" sz="1600" dirty="0"/>
                     </a:p>
@@ -7756,77 +7852,75 @@
                     <a:p>
                       <a:pPr latinLnBrk="1"/>
                       <a:r>
-                        <a:rPr lang="ko-KR" altLang="en-US" sz="1600" dirty="0" smtClean="0"/>
-                        <a:t>캐릭터 애니메이션 </a:t>
-                      </a:r>
-                      <a:r>
-                        <a:rPr lang="ko-KR" altLang="en-US" sz="1600" dirty="0" err="1" smtClean="0"/>
-                        <a:t>블렌드</a:t>
-                      </a:r>
-                      <a:r>
-                        <a:rPr lang="en-US" altLang="ko-KR" sz="1600" dirty="0" smtClean="0"/>
+                        <a:rPr lang="ko-KR" altLang="en-US" sz="1600" dirty="0"/>
+                        <a:t>높이에 따른 장애물</a:t>
+                      </a:r>
+                      <a:r>
+                        <a:rPr lang="ko-KR" altLang="en-US" sz="1600" baseline="0" dirty="0"/>
+                        <a:t> </a:t>
+                      </a:r>
+                      <a:r>
+                        <a:rPr lang="ko-KR" altLang="en-US" sz="1600" baseline="0" dirty="0" err="1"/>
+                        <a:t>파쿠르</a:t>
+                      </a:r>
+                      <a:r>
+                        <a:rPr lang="ko-KR" altLang="en-US" sz="1600" baseline="0" dirty="0"/>
+                        <a:t> 처리</a:t>
+                      </a:r>
+                      <a:r>
+                        <a:rPr lang="en-US" altLang="ko-KR" sz="1600" baseline="0" dirty="0"/>
                         <a:t>, </a:t>
                       </a:r>
                       <a:r>
-                        <a:rPr lang="ko-KR" altLang="en-US" sz="1600" dirty="0" smtClean="0"/>
-                        <a:t>애니메이션 </a:t>
-                      </a:r>
-                      <a:r>
-                        <a:rPr lang="ko-KR" altLang="en-US" sz="1600" dirty="0" err="1" smtClean="0"/>
-                        <a:t>상태머신</a:t>
-                      </a:r>
-                      <a:r>
-                        <a:rPr lang="en-US" altLang="ko-KR" sz="1600" dirty="0" smtClean="0"/>
-                        <a:t>,</a:t>
-                      </a:r>
-                    </a:p>
-                    <a:p>
-                      <a:pPr latinLnBrk="1"/>
-                      <a:r>
-                        <a:rPr lang="ko-KR" altLang="en-US" sz="1600" dirty="0" smtClean="0"/>
-                        <a:t>물리엔진</a:t>
-                      </a:r>
-                      <a:r>
-                        <a:rPr lang="en-US" altLang="ko-KR" sz="1600" dirty="0" smtClean="0"/>
-                        <a:t>(PhysX) </a:t>
-                      </a:r>
-                      <a:r>
-                        <a:rPr lang="ko-KR" altLang="en-US" sz="1600" dirty="0" smtClean="0"/>
-                        <a:t>적용</a:t>
-                      </a:r>
-                      <a:r>
-                        <a:rPr lang="en-US" altLang="ko-KR" sz="1600" dirty="0" smtClean="0"/>
+                        <a:rPr lang="ko-KR" altLang="en-US" sz="1600" dirty="0"/>
+                        <a:t>평지</a:t>
+                      </a:r>
+                      <a:r>
+                        <a:rPr lang="en-US" altLang="ko-KR" sz="1600" dirty="0"/>
+                        <a:t>-</a:t>
+                      </a:r>
+                      <a:r>
+                        <a:rPr lang="ko-KR" altLang="en-US" sz="1600" dirty="0"/>
+                        <a:t>벽면 간 애니메이션</a:t>
+                      </a:r>
+                      <a:r>
+                        <a:rPr lang="ko-KR" altLang="en-US" sz="1600" baseline="0" dirty="0"/>
+                        <a:t> 상태</a:t>
+                      </a:r>
+                      <a:r>
+                        <a:rPr lang="ko-KR" altLang="en-US" sz="1600" dirty="0"/>
+                        <a:t> 전환</a:t>
+                      </a:r>
+                      <a:r>
+                        <a:rPr lang="en-US" altLang="ko-KR" sz="1600" baseline="0" dirty="0"/>
+                        <a:t> (</a:t>
+                      </a:r>
+                      <a:r>
+                        <a:rPr lang="ko-KR" altLang="en-US" sz="1600" baseline="0" dirty="0"/>
+                        <a:t>벽면을 올라 평지에 도달</a:t>
+                      </a:r>
+                      <a:r>
+                        <a:rPr lang="en-US" altLang="ko-KR" sz="1600" baseline="0" dirty="0"/>
                         <a:t>, </a:t>
                       </a:r>
                       <a:r>
-                        <a:rPr lang="ko-KR" altLang="en-US" sz="1600" dirty="0" smtClean="0"/>
-                        <a:t>캐릭터 입력 </a:t>
-                      </a:r>
-                      <a:r>
-                        <a:rPr lang="ko-KR" altLang="en-US" sz="1600" dirty="0" smtClean="0"/>
-                        <a:t>바인딩</a:t>
-                      </a:r>
-                      <a:r>
-                        <a:rPr lang="en-US" altLang="ko-KR" sz="1600" dirty="0" smtClean="0"/>
-                        <a:t>, </a:t>
-                      </a:r>
-                      <a:r>
-                        <a:rPr lang="ko-KR" altLang="en-US" sz="1600" dirty="0" smtClean="0"/>
-                        <a:t>캐릭터 </a:t>
-                      </a:r>
-                      <a:r>
-                        <a:rPr lang="ko-KR" altLang="en-US" sz="1600" dirty="0" err="1" smtClean="0"/>
-                        <a:t>로코모션</a:t>
-                      </a:r>
-                      <a:r>
-                        <a:rPr lang="ko-KR" altLang="en-US" sz="1600" dirty="0" smtClean="0"/>
-                        <a:t> 적용</a:t>
-                      </a:r>
-                      <a:endParaRPr lang="ko-KR" altLang="en-US" sz="1600" dirty="0"/>
+                        <a:rPr lang="ko-KR" altLang="en-US" sz="1600" baseline="0" dirty="0"/>
+                        <a:t>벽면에서 내려와 평지에 도달 등</a:t>
+                      </a:r>
+                      <a:r>
+                        <a:rPr lang="en-US" altLang="ko-KR" sz="1600" baseline="0" dirty="0"/>
+                        <a:t>)</a:t>
+                      </a:r>
+                      <a:endParaRPr lang="en-US" altLang="ko-KR" sz="1600" dirty="0"/>
                     </a:p>
                   </a:txBody>
                   <a:tcPr/>
                 </a:tc>
+                <a:extLst>
+                  <a:ext uri="{0D108BD9-81ED-4DB2-BD59-A6C34878D82A}">
+                    <a16:rowId xmlns:a16="http://schemas.microsoft.com/office/drawing/2014/main" val="10004"/>
+                  </a:ext>
+                </a:extLst>
               </a:tr>
               <a:tr h="627956">
                 <a:tc>
@@ -7836,8 +7930,8 @@
                     <a:p>
                       <a:pPr algn="ctr" latinLnBrk="1"/>
                       <a:r>
-                        <a:rPr lang="en-US" altLang="ko-KR" dirty="0" smtClean="0"/>
-                        <a:t>3</a:t>
+                        <a:rPr lang="en-US" altLang="ko-KR" dirty="0"/>
+                        <a:t>5</a:t>
                       </a:r>
                       <a:endParaRPr lang="ko-KR" altLang="en-US" dirty="0"/>
                     </a:p>
@@ -7851,30 +7945,13 @@
                     <a:p>
                       <a:pPr latinLnBrk="1"/>
                       <a:r>
-                        <a:rPr lang="ko-KR" altLang="en-US" sz="1600" dirty="0" smtClean="0"/>
-                        <a:t>씬 배치</a:t>
-                      </a:r>
-                      <a:r>
-                        <a:rPr lang="en-US" altLang="ko-KR" sz="1600" dirty="0" smtClean="0"/>
-                        <a:t>, </a:t>
-                      </a:r>
-                      <a:r>
-                        <a:rPr lang="ko-KR" altLang="en-US" sz="1600" dirty="0" smtClean="0"/>
-                        <a:t>캐릭터</a:t>
-                      </a:r>
-                      <a:r>
-                        <a:rPr lang="en-US" altLang="ko-KR" sz="1600" dirty="0" smtClean="0"/>
-                        <a:t> </a:t>
-                      </a:r>
-                      <a:r>
-                        <a:rPr lang="ko-KR" altLang="en-US" sz="1600" dirty="0" err="1" smtClean="0"/>
+                        <a:rPr lang="ko-KR" altLang="en-US" sz="1600" dirty="0" err="1"/>
                         <a:t>파쿠르</a:t>
                       </a:r>
                       <a:r>
-                        <a:rPr lang="ko-KR" altLang="en-US" sz="1600" dirty="0" smtClean="0"/>
-                        <a:t> 애니메이션 적용</a:t>
-                      </a:r>
-                      <a:endParaRPr lang="ko-KR" altLang="en-US" sz="1600" dirty="0"/>
+                        <a:rPr lang="ko-KR" altLang="en-US" sz="1600" dirty="0"/>
+                        <a:t> 시스템 보완</a:t>
+                      </a:r>
                     </a:p>
                   </a:txBody>
                   <a:tcPr/>
@@ -7886,65 +7963,55 @@
                     <a:p>
                       <a:pPr latinLnBrk="1"/>
                       <a:r>
-                        <a:rPr lang="ko-KR" altLang="en-US" sz="1600" dirty="0" smtClean="0"/>
-                        <a:t>씬</a:t>
-                      </a:r>
-                      <a:r>
-                        <a:rPr lang="en-US" altLang="ko-KR" sz="1600" baseline="0" dirty="0" smtClean="0"/>
+                        <a:rPr lang="ko-KR" altLang="en-US" sz="1600" dirty="0"/>
+                        <a:t>애니메이션 </a:t>
+                      </a:r>
+                      <a:r>
+                        <a:rPr lang="en-US" altLang="ko-KR" sz="1600" dirty="0"/>
+                        <a:t>IK </a:t>
+                      </a:r>
+                      <a:r>
+                        <a:rPr lang="ko-KR" altLang="en-US" sz="1600" dirty="0"/>
+                        <a:t>적용</a:t>
+                      </a:r>
+                      <a:r>
+                        <a:rPr lang="en-US" altLang="ko-KR" sz="1600" dirty="0"/>
+                        <a:t>, </a:t>
+                      </a:r>
+                      <a:r>
+                        <a:rPr lang="ko-KR" altLang="en-US" sz="1600" dirty="0" err="1"/>
+                        <a:t>파쿠르</a:t>
+                      </a:r>
+                      <a:r>
+                        <a:rPr lang="ko-KR" altLang="en-US" sz="1600" dirty="0"/>
+                        <a:t> 시</a:t>
+                      </a:r>
+                      <a:r>
+                        <a:rPr lang="en-US" altLang="ko-KR" sz="1600" dirty="0"/>
                         <a:t> </a:t>
                       </a:r>
                       <a:r>
-                        <a:rPr lang="ko-KR" altLang="en-US" sz="1600" baseline="0" dirty="0" smtClean="0"/>
-                        <a:t>데이터 직렬화 </a:t>
-                      </a:r>
-                      <a:r>
-                        <a:rPr lang="en-US" altLang="ko-KR" sz="1600" baseline="0" dirty="0" smtClean="0"/>
-                        <a:t>(</a:t>
-                      </a:r>
-                      <a:r>
-                        <a:rPr lang="ko-KR" altLang="en-US" sz="1600" baseline="0" dirty="0" smtClean="0"/>
-                        <a:t>장애물 배치 정보</a:t>
-                      </a:r>
-                      <a:r>
-                        <a:rPr lang="en-US" altLang="ko-KR" sz="1600" baseline="0" dirty="0" smtClean="0"/>
-                        <a:t>), </a:t>
-                      </a:r>
-                      <a:r>
-                        <a:rPr lang="ko-KR" altLang="en-US" sz="1600" baseline="0" dirty="0" smtClean="0"/>
-                        <a:t>장애물 높이 인식</a:t>
-                      </a:r>
-                      <a:r>
-                        <a:rPr lang="en-US" altLang="ko-KR" sz="1600" baseline="0" dirty="0" smtClean="0"/>
-                        <a:t>, </a:t>
-                      </a:r>
-                      <a:br>
-                        <a:rPr lang="en-US" altLang="ko-KR" sz="1600" baseline="0" dirty="0" smtClean="0"/>
-                      </a:br>
-                      <a:r>
-                        <a:rPr lang="ko-KR" altLang="en-US" sz="1600" baseline="0" dirty="0" smtClean="0"/>
-                        <a:t>인식한 장애물에 대한 </a:t>
-                      </a:r>
-                      <a:r>
-                        <a:rPr lang="ko-KR" altLang="en-US" sz="1600" baseline="0" dirty="0" err="1" smtClean="0"/>
-                        <a:t>파쿠르</a:t>
-                      </a:r>
-                      <a:r>
-                        <a:rPr lang="ko-KR" altLang="en-US" sz="1600" baseline="0" dirty="0" smtClean="0"/>
-                        <a:t> 애니메이션 선택</a:t>
-                      </a:r>
-                      <a:r>
-                        <a:rPr lang="en-US" altLang="ko-KR" sz="1600" baseline="0" dirty="0" smtClean="0"/>
-                        <a:t> </a:t>
-                      </a:r>
-                      <a:r>
-                        <a:rPr lang="ko-KR" altLang="en-US" sz="1600" baseline="0" dirty="0" smtClean="0"/>
-                        <a:t>및 출력</a:t>
-                      </a:r>
-                      <a:endParaRPr lang="ko-KR" altLang="en-US" sz="1600" dirty="0"/>
+                        <a:rPr lang="ko-KR" altLang="en-US" sz="1600" dirty="0"/>
+                        <a:t>캐릭터 손 위치 </a:t>
+                      </a:r>
+                      <a:r>
+                        <a:rPr lang="en-US" altLang="ko-KR" sz="1600" dirty="0"/>
+                        <a:t>IK</a:t>
+                      </a:r>
+                      <a:r>
+                        <a:rPr lang="ko-KR" altLang="en-US" sz="1600" dirty="0"/>
+                        <a:t>를 통해 보정</a:t>
+                      </a:r>
+                      <a:endParaRPr lang="en-US" altLang="ko-KR" sz="1600" dirty="0"/>
                     </a:p>
                   </a:txBody>
                   <a:tcPr/>
                 </a:tc>
+                <a:extLst>
+                  <a:ext uri="{0D108BD9-81ED-4DB2-BD59-A6C34878D82A}">
+                    <a16:rowId xmlns:a16="http://schemas.microsoft.com/office/drawing/2014/main" val="10005"/>
+                  </a:ext>
+                </a:extLst>
               </a:tr>
               <a:tr h="627956">
                 <a:tc>
@@ -7954,8 +8021,8 @@
                     <a:p>
                       <a:pPr algn="ctr" latinLnBrk="1"/>
                       <a:r>
-                        <a:rPr lang="en-US" altLang="ko-KR" dirty="0" smtClean="0"/>
-                        <a:t>4</a:t>
+                        <a:rPr lang="en-US" altLang="ko-KR" dirty="0"/>
+                        <a:t>6</a:t>
                       </a:r>
                       <a:endParaRPr lang="ko-KR" altLang="en-US" dirty="0"/>
                     </a:p>
@@ -7969,18 +8036,9 @@
                     <a:p>
                       <a:pPr latinLnBrk="1"/>
                       <a:r>
-                        <a:rPr lang="ko-KR" altLang="en-US" sz="1600" dirty="0" err="1" smtClean="0"/>
-                        <a:t>파쿠르</a:t>
-                      </a:r>
-                      <a:r>
-                        <a:rPr lang="ko-KR" altLang="en-US" sz="1600" dirty="0" smtClean="0"/>
-                        <a:t> </a:t>
-                      </a:r>
-                      <a:r>
-                        <a:rPr lang="ko-KR" altLang="en-US" sz="1600" dirty="0" err="1" smtClean="0"/>
-                        <a:t>프로토타입</a:t>
-                      </a:r>
-                      <a:endParaRPr lang="ko-KR" altLang="en-US" sz="1600" dirty="0"/>
+                        <a:rPr lang="ko-KR" altLang="en-US" sz="1600" dirty="0"/>
+                        <a:t>복잡한 지형 애니메이션 처리</a:t>
+                      </a:r>
                     </a:p>
                   </a:txBody>
                   <a:tcPr/>
@@ -7992,239 +8050,46 @@
                     <a:p>
                       <a:pPr latinLnBrk="1"/>
                       <a:r>
-                        <a:rPr lang="ko-KR" altLang="en-US" sz="1600" dirty="0" smtClean="0"/>
-                        <a:t>높이에 따른 장애물</a:t>
-                      </a:r>
-                      <a:r>
-                        <a:rPr lang="ko-KR" altLang="en-US" sz="1600" baseline="0" dirty="0" smtClean="0"/>
-                        <a:t> </a:t>
-                      </a:r>
-                      <a:r>
-                        <a:rPr lang="ko-KR" altLang="en-US" sz="1600" baseline="0" dirty="0" err="1" smtClean="0"/>
+                        <a:rPr lang="ko-KR" altLang="en-US" sz="1600" baseline="0" dirty="0"/>
+                        <a:t>벽면 중간에 지붕</a:t>
+                      </a:r>
+                      <a:r>
+                        <a:rPr lang="en-US" altLang="ko-KR" sz="1600" baseline="0" dirty="0"/>
+                        <a:t>, </a:t>
+                      </a:r>
+                      <a:r>
+                        <a:rPr lang="ko-KR" altLang="en-US" sz="1600" baseline="0" dirty="0"/>
+                        <a:t>경사로</a:t>
+                      </a:r>
+                      <a:r>
+                        <a:rPr lang="en-US" altLang="ko-KR" sz="1600" baseline="0" dirty="0"/>
+                        <a:t>, </a:t>
+                      </a:r>
+                      <a:r>
+                        <a:rPr lang="ko-KR" altLang="en-US" sz="1600" baseline="0" dirty="0"/>
+                        <a:t>철봉 나열된 환경</a:t>
+                      </a:r>
+                      <a:br>
+                        <a:rPr lang="en-US" altLang="ko-KR" sz="1600" baseline="0" dirty="0"/>
+                      </a:br>
+                      <a:r>
+                        <a:rPr lang="ko-KR" altLang="en-US" sz="1600" baseline="0" dirty="0" err="1"/>
                         <a:t>파쿠르</a:t>
                       </a:r>
                       <a:r>
-                        <a:rPr lang="ko-KR" altLang="en-US" sz="1600" baseline="0" dirty="0" smtClean="0"/>
-                        <a:t> 처리</a:t>
-                      </a:r>
-                      <a:r>
-                        <a:rPr lang="en-US" altLang="ko-KR" sz="1600" baseline="0" dirty="0" smtClean="0"/>
-                        <a:t>, </a:t>
-                      </a:r>
-                      <a:r>
-                        <a:rPr lang="ko-KR" altLang="en-US" sz="1600" dirty="0" smtClean="0"/>
-                        <a:t>평지</a:t>
-                      </a:r>
-                      <a:r>
-                        <a:rPr lang="en-US" altLang="ko-KR" sz="1600" dirty="0" smtClean="0"/>
-                        <a:t>-</a:t>
-                      </a:r>
-                      <a:r>
-                        <a:rPr lang="ko-KR" altLang="en-US" sz="1600" dirty="0" smtClean="0"/>
-                        <a:t>벽면 간 애니메이션</a:t>
-                      </a:r>
-                      <a:r>
-                        <a:rPr lang="ko-KR" altLang="en-US" sz="1600" baseline="0" dirty="0" smtClean="0"/>
-                        <a:t> 상태</a:t>
-                      </a:r>
-                      <a:r>
-                        <a:rPr lang="ko-KR" altLang="en-US" sz="1600" dirty="0" smtClean="0"/>
-                        <a:t> 전환</a:t>
-                      </a:r>
-                      <a:r>
-                        <a:rPr lang="en-US" altLang="ko-KR" sz="1600" baseline="0" dirty="0" smtClean="0"/>
-                        <a:t> (</a:t>
-                      </a:r>
-                      <a:r>
-                        <a:rPr lang="ko-KR" altLang="en-US" sz="1600" baseline="0" dirty="0" smtClean="0"/>
-                        <a:t>벽면을 올라 평지에 도달</a:t>
-                      </a:r>
-                      <a:r>
-                        <a:rPr lang="en-US" altLang="ko-KR" sz="1600" baseline="0" dirty="0" smtClean="0"/>
-                        <a:t>, </a:t>
-                      </a:r>
-                      <a:r>
-                        <a:rPr lang="ko-KR" altLang="en-US" sz="1600" baseline="0" dirty="0" smtClean="0"/>
-                        <a:t>벽면에서 내려와 평지에 도달 등</a:t>
-                      </a:r>
-                      <a:r>
-                        <a:rPr lang="en-US" altLang="ko-KR" sz="1600" baseline="0" dirty="0" smtClean="0"/>
-                        <a:t>)</a:t>
-                      </a:r>
-                      <a:endParaRPr lang="en-US" altLang="ko-KR" sz="1600" dirty="0" smtClean="0"/>
-                    </a:p>
-                  </a:txBody>
-                  <a:tcPr/>
-                </a:tc>
-              </a:tr>
-              <a:tr h="627956">
-                <a:tc>
-                  <a:txBody>
-                    <a:bodyPr/>
-                    <a:lstStyle/>
-                    <a:p>
-                      <a:pPr algn="ctr" latinLnBrk="1"/>
-                      <a:r>
-                        <a:rPr lang="en-US" altLang="ko-KR" dirty="0" smtClean="0"/>
-                        <a:t>5</a:t>
-                      </a:r>
-                      <a:endParaRPr lang="ko-KR" altLang="en-US" dirty="0"/>
-                    </a:p>
-                  </a:txBody>
-                  <a:tcPr/>
-                </a:tc>
-                <a:tc>
-                  <a:txBody>
-                    <a:bodyPr/>
-                    <a:lstStyle/>
-                    <a:p>
-                      <a:pPr latinLnBrk="1"/>
-                      <a:r>
-                        <a:rPr lang="ko-KR" altLang="en-US" sz="1600" dirty="0" err="1" smtClean="0"/>
-                        <a:t>파쿠르</a:t>
-                      </a:r>
-                      <a:r>
-                        <a:rPr lang="ko-KR" altLang="en-US" sz="1600" dirty="0" smtClean="0"/>
-                        <a:t> 시스템 보완</a:t>
+                        <a:rPr lang="ko-KR" altLang="en-US" sz="1600" baseline="0" dirty="0"/>
+                        <a:t> 애니메이션 처리</a:t>
                       </a:r>
                       <a:endParaRPr lang="ko-KR" altLang="en-US" sz="1600" dirty="0"/>
                     </a:p>
                   </a:txBody>
                   <a:tcPr/>
                 </a:tc>
-                <a:tc>
-                  <a:txBody>
-                    <a:bodyPr/>
-                    <a:lstStyle/>
-                    <a:p>
-                      <a:pPr latinLnBrk="1"/>
-                      <a:r>
-                        <a:rPr lang="ko-KR" altLang="en-US" sz="1600" dirty="0" smtClean="0"/>
-                        <a:t>애니메이션 </a:t>
-                      </a:r>
-                      <a:r>
-                        <a:rPr lang="en-US" altLang="ko-KR" sz="1600" dirty="0" smtClean="0"/>
-                        <a:t>IK </a:t>
-                      </a:r>
-                      <a:r>
-                        <a:rPr lang="ko-KR" altLang="en-US" sz="1600" dirty="0" smtClean="0"/>
-                        <a:t>적용</a:t>
-                      </a:r>
-                      <a:r>
-                        <a:rPr lang="en-US" altLang="ko-KR" sz="1600" dirty="0" smtClean="0"/>
-                        <a:t>, </a:t>
-                      </a:r>
-                      <a:r>
-                        <a:rPr lang="ko-KR" altLang="en-US" sz="1600" dirty="0" err="1" smtClean="0"/>
-                        <a:t>파쿠르</a:t>
-                      </a:r>
-                      <a:r>
-                        <a:rPr lang="ko-KR" altLang="en-US" sz="1600" dirty="0" smtClean="0"/>
-                        <a:t> 시</a:t>
-                      </a:r>
-                      <a:r>
-                        <a:rPr lang="en-US" altLang="ko-KR" sz="1600" dirty="0" smtClean="0"/>
-                        <a:t> </a:t>
-                      </a:r>
-                      <a:r>
-                        <a:rPr lang="ko-KR" altLang="en-US" sz="1600" dirty="0" smtClean="0"/>
-                        <a:t>캐릭터 손 위치 </a:t>
-                      </a:r>
-                      <a:r>
-                        <a:rPr lang="en-US" altLang="ko-KR" sz="1600" dirty="0" smtClean="0"/>
-                        <a:t>IK</a:t>
-                      </a:r>
-                      <a:r>
-                        <a:rPr lang="ko-KR" altLang="en-US" sz="1600" dirty="0" smtClean="0"/>
-                        <a:t>를 통해 보정</a:t>
-                      </a:r>
-                      <a:endParaRPr lang="en-US" altLang="ko-KR" sz="1600" dirty="0" smtClean="0"/>
-                    </a:p>
-                  </a:txBody>
-                  <a:tcPr/>
-                </a:tc>
-              </a:tr>
-              <a:tr h="627956">
-                <a:tc>
-                  <a:txBody>
-                    <a:bodyPr/>
-                    <a:lstStyle/>
-                    <a:p>
-                      <a:pPr algn="ctr" latinLnBrk="1"/>
-                      <a:r>
-                        <a:rPr lang="en-US" altLang="ko-KR" dirty="0" smtClean="0"/>
-                        <a:t>6</a:t>
-                      </a:r>
-                      <a:endParaRPr lang="ko-KR" altLang="en-US" dirty="0"/>
-                    </a:p>
-                  </a:txBody>
-                  <a:tcPr/>
-                </a:tc>
-                <a:tc>
-                  <a:txBody>
-                    <a:bodyPr/>
-                    <a:lstStyle/>
-                    <a:p>
-                      <a:pPr latinLnBrk="1"/>
-                      <a:r>
-                        <a:rPr lang="ko-KR" altLang="en-US" sz="1600" dirty="0" smtClean="0"/>
-                        <a:t>복잡한 </a:t>
-                      </a:r>
-                      <a:r>
-                        <a:rPr lang="ko-KR" altLang="en-US" sz="1600" dirty="0" smtClean="0"/>
-                        <a:t>지형 애니메이션 처리</a:t>
-                      </a:r>
-                      <a:endParaRPr lang="ko-KR" altLang="en-US" sz="1600" dirty="0"/>
-                    </a:p>
-                  </a:txBody>
-                  <a:tcPr/>
-                </a:tc>
-                <a:tc>
-                  <a:txBody>
-                    <a:bodyPr/>
-                    <a:lstStyle/>
-                    <a:p>
-                      <a:pPr latinLnBrk="1"/>
-                      <a:r>
-                        <a:rPr lang="ko-KR" altLang="en-US" sz="1600" baseline="0" dirty="0" smtClean="0"/>
-                        <a:t>벽면 중간에 지붕</a:t>
-                      </a:r>
-                      <a:r>
-                        <a:rPr lang="en-US" altLang="ko-KR" sz="1600" baseline="0" dirty="0" smtClean="0"/>
-                        <a:t>, </a:t>
-                      </a:r>
-                      <a:r>
-                        <a:rPr lang="ko-KR" altLang="en-US" sz="1600" baseline="0" dirty="0" smtClean="0"/>
-                        <a:t>경사로</a:t>
-                      </a:r>
-                      <a:r>
-                        <a:rPr lang="en-US" altLang="ko-KR" sz="1600" baseline="0" dirty="0" smtClean="0"/>
-                        <a:t>, </a:t>
-                      </a:r>
-                      <a:r>
-                        <a:rPr lang="ko-KR" altLang="en-US" sz="1600" baseline="0" dirty="0" smtClean="0"/>
-                        <a:t>철봉 나열된 환경</a:t>
-                      </a:r>
-                      <a:r>
-                        <a:rPr lang="en-US" altLang="ko-KR" sz="1600" baseline="0" dirty="0" smtClean="0"/>
-                        <a:t/>
-                      </a:r>
-                      <a:br>
-                        <a:rPr lang="en-US" altLang="ko-KR" sz="1600" baseline="0" dirty="0" smtClean="0"/>
-                      </a:br>
-                      <a:r>
-                        <a:rPr lang="ko-KR" altLang="en-US" sz="1600" baseline="0" dirty="0" err="1" smtClean="0"/>
-                        <a:t>파쿠르</a:t>
-                      </a:r>
-                      <a:r>
-                        <a:rPr lang="ko-KR" altLang="en-US" sz="1600" baseline="0" dirty="0" smtClean="0"/>
-                        <a:t> 애니메이션 처리</a:t>
-                      </a:r>
-                      <a:endParaRPr lang="ko-KR" altLang="en-US" sz="1600" dirty="0"/>
-                    </a:p>
-                  </a:txBody>
-                  <a:tcPr/>
-                </a:tc>
+                <a:extLst>
+                  <a:ext uri="{0D108BD9-81ED-4DB2-BD59-A6C34878D82A}">
+                    <a16:rowId xmlns:a16="http://schemas.microsoft.com/office/drawing/2014/main" val="10006"/>
+                  </a:ext>
+                </a:extLst>
               </a:tr>
               <a:tr h="611544">
                 <a:tc>
@@ -8234,7 +8099,7 @@
                     <a:p>
                       <a:pPr algn="ctr" latinLnBrk="1"/>
                       <a:r>
-                        <a:rPr lang="en-US" altLang="ko-KR" dirty="0" smtClean="0"/>
+                        <a:rPr lang="en-US" altLang="ko-KR" dirty="0"/>
                         <a:t>7</a:t>
                       </a:r>
                       <a:endParaRPr lang="ko-KR" altLang="en-US" dirty="0"/>
@@ -8265,7 +8130,7 @@
                         <a:defRPr/>
                       </a:pPr>
                       <a:r>
-                        <a:rPr lang="ko-KR" altLang="en-US" sz="1600" dirty="0" smtClean="0"/>
+                        <a:rPr lang="ko-KR" altLang="en-US" sz="1600" dirty="0"/>
                         <a:t>복잡한 지형 애니메이션 처리</a:t>
                       </a:r>
                     </a:p>
@@ -8283,27 +8148,27 @@
                     <a:p>
                       <a:pPr latinLnBrk="1"/>
                       <a:r>
-                        <a:rPr lang="ko-KR" altLang="en-US" sz="1600" dirty="0" smtClean="0"/>
+                        <a:rPr lang="ko-KR" altLang="en-US" sz="1600" dirty="0"/>
                         <a:t>직각으로 만나는 벽면 간 이동 처리</a:t>
                       </a:r>
                       <a:r>
-                        <a:rPr lang="en-US" altLang="ko-KR" sz="1600" dirty="0" smtClean="0"/>
+                        <a:rPr lang="en-US" altLang="ko-KR" sz="1600" dirty="0"/>
                         <a:t>, </a:t>
                       </a:r>
                       <a:r>
-                        <a:rPr lang="ko-KR" altLang="en-US" sz="1600" dirty="0" smtClean="0"/>
+                        <a:rPr lang="ko-KR" altLang="en-US" sz="1600" dirty="0"/>
                         <a:t>벽면에 뻗어 나온 줄 또는 기둥</a:t>
                       </a:r>
                       <a:r>
-                        <a:rPr lang="ko-KR" altLang="en-US" sz="1600" baseline="0" dirty="0" smtClean="0"/>
+                        <a:rPr lang="ko-KR" altLang="en-US" sz="1600" baseline="0" dirty="0"/>
                         <a:t> 환경 </a:t>
                       </a:r>
                       <a:r>
-                        <a:rPr lang="ko-KR" altLang="en-US" sz="1600" baseline="0" dirty="0" err="1" smtClean="0"/>
+                        <a:rPr lang="ko-KR" altLang="en-US" sz="1600" baseline="0" dirty="0" err="1"/>
                         <a:t>파쿠르</a:t>
                       </a:r>
                       <a:r>
-                        <a:rPr lang="ko-KR" altLang="en-US" sz="1600" baseline="0" dirty="0" smtClean="0"/>
+                        <a:rPr lang="ko-KR" altLang="en-US" sz="1600" baseline="0" dirty="0"/>
                         <a:t> 애니메이션 처리</a:t>
                       </a:r>
                       <a:endParaRPr lang="ko-KR" altLang="en-US" sz="1600" dirty="0"/>
@@ -8311,6 +8176,11 @@
                   </a:txBody>
                   <a:tcPr/>
                 </a:tc>
+                <a:extLst>
+                  <a:ext uri="{0D108BD9-81ED-4DB2-BD59-A6C34878D82A}">
+                    <a16:rowId xmlns:a16="http://schemas.microsoft.com/office/drawing/2014/main" val="10007"/>
+                  </a:ext>
+                </a:extLst>
               </a:tr>
               <a:tr h="611544">
                 <a:tc>
@@ -8320,7 +8190,7 @@
                     <a:p>
                       <a:pPr algn="ctr" latinLnBrk="1"/>
                       <a:r>
-                        <a:rPr lang="en-US" altLang="ko-KR" dirty="0" smtClean="0"/>
+                        <a:rPr lang="en-US" altLang="ko-KR" dirty="0"/>
                         <a:t>8</a:t>
                       </a:r>
                       <a:endParaRPr lang="ko-KR" altLang="en-US" dirty="0"/>
@@ -8335,10 +8205,9 @@
                     <a:p>
                       <a:pPr latinLnBrk="1"/>
                       <a:r>
-                        <a:rPr lang="ko-KR" altLang="en-US" sz="1600" dirty="0" smtClean="0"/>
+                        <a:rPr lang="ko-KR" altLang="en-US" sz="1600" dirty="0"/>
                         <a:t>마무리 및 보완</a:t>
                       </a:r>
-                      <a:endParaRPr lang="ko-KR" altLang="en-US" sz="1600" dirty="0"/>
                     </a:p>
                   </a:txBody>
                   <a:tcPr/>
@@ -8350,14 +8219,18 @@
                     <a:p>
                       <a:pPr latinLnBrk="1"/>
                       <a:r>
-                        <a:rPr lang="ko-KR" altLang="en-US" sz="1600" dirty="0" smtClean="0"/>
+                        <a:rPr lang="ko-KR" altLang="en-US" sz="1600" dirty="0"/>
                         <a:t>테스트 및 미흡사항 보완</a:t>
                       </a:r>
-                      <a:endParaRPr lang="ko-KR" altLang="en-US" sz="1600" dirty="0"/>
                     </a:p>
                   </a:txBody>
                   <a:tcPr/>
                 </a:tc>
+                <a:extLst>
+                  <a:ext uri="{0D108BD9-81ED-4DB2-BD59-A6C34878D82A}">
+                    <a16:rowId xmlns:a16="http://schemas.microsoft.com/office/drawing/2014/main" val="10008"/>
+                  </a:ext>
+                </a:extLst>
               </a:tr>
             </a:tbl>
           </a:graphicData>
@@ -8373,13 +8246,6 @@
   <p:clrMapOvr>
     <a:masterClrMapping/>
   </p:clrMapOvr>
-  <p:timing>
-    <p:tnLst>
-      <p:par>
-        <p:cTn id="1" dur="indefinite" restart="never" nodeType="tmRoot"/>
-      </p:par>
-    </p:tnLst>
-  </p:timing>
 </p:sld>
 </file>
 

</xml_diff>